<commit_message>
Rebalance emotional benchmark slide with positive indicators
Co-authored-by: EmberEnterprises <EmberEnterprises@users.noreply.github.com>
</commit_message>
<xml_diff>
--- a/public/Stillform_Executive_Deck.pptx
+++ b/public/Stillform_Executive_Deck.pptx
@@ -132,18 +132,18 @@
               <c:strCache>
                 <c:ptCount val="1"/>
                 <c:pt idx="0">
-                  <c:v>Global adults (%)</c:v>
+                  <c:v>Negative emotions (%)</c:v>
                 </c:pt>
               </c:strCache>
             </c:strRef>
           </c:tx>
           <c:spPr>
             <a:solidFill>
-              <a:srgbClr val="EBAB4A"/>
+              <a:srgbClr val="D76060"/>
             </a:solidFill>
             <a:ln>
               <a:solidFill>
-                <a:srgbClr val="EBAB4A"/>
+                <a:srgbClr val="D76060"/>
               </a:solidFill>
             </a:ln>
           </c:spPr>
@@ -285,6 +285,176 @@
 </file>
 
 <file path=ppt/charts/chart2.xml><?xml version="1.0" encoding="utf-8"?>
+<c:chartSpace xmlns:c="http://schemas.openxmlformats.org/drawingml/2006/chart" xmlns:a="http://schemas.openxmlformats.org/drawingml/2006/main" xmlns:r="http://schemas.openxmlformats.org/officeDocument/2006/relationships">
+  <c:date1904 val="0"/>
+  <c:chart>
+    <c:autoTitleDeleted val="0"/>
+    <c:plotArea>
+      <c:barChart>
+        <c:barDir val="bar"/>
+        <c:grouping val="clustered"/>
+        <c:ser>
+          <c:idx val="0"/>
+          <c:order val="0"/>
+          <c:tx>
+            <c:strRef>
+              <c:f>Sheet1!$B$1</c:f>
+              <c:strCache>
+                <c:ptCount val="1"/>
+                <c:pt idx="0">
+                  <c:v>Positive experiences (%)</c:v>
+                </c:pt>
+              </c:strCache>
+            </c:strRef>
+          </c:tx>
+          <c:spPr>
+            <a:solidFill>
+              <a:srgbClr val="63BF93"/>
+            </a:solidFill>
+            <a:ln>
+              <a:solidFill>
+                <a:srgbClr val="63BF93"/>
+              </a:solidFill>
+            </a:ln>
+          </c:spPr>
+          <c:cat>
+            <c:strRef>
+              <c:f>Sheet1!$A$2:$A$6</c:f>
+              <c:strCache>
+                <c:ptCount val="5"/>
+                <c:pt idx="0">
+                  <c:v>Respect</c:v>
+                </c:pt>
+                <c:pt idx="1">
+                  <c:v>Laughter</c:v>
+                </c:pt>
+                <c:pt idx="2">
+                  <c:v>Enjoyment</c:v>
+                </c:pt>
+                <c:pt idx="3">
+                  <c:v>Well-rested</c:v>
+                </c:pt>
+                <c:pt idx="4">
+                  <c:v>Learned</c:v>
+                </c:pt>
+              </c:strCache>
+            </c:strRef>
+          </c:cat>
+          <c:val>
+            <c:numRef>
+              <c:f>Sheet1!$B$2:$B$6</c:f>
+              <c:numCache>
+                <c:formatCode>General</c:formatCode>
+                <c:ptCount val="5"/>
+                <c:pt idx="0">
+                  <c:v>88</c:v>
+                </c:pt>
+                <c:pt idx="1">
+                  <c:v>73</c:v>
+                </c:pt>
+                <c:pt idx="2">
+                  <c:v>73</c:v>
+                </c:pt>
+                <c:pt idx="3">
+                  <c:v>72</c:v>
+                </c:pt>
+                <c:pt idx="4">
+                  <c:v>52</c:v>
+                </c:pt>
+              </c:numCache>
+            </c:numRef>
+          </c:val>
+        </c:ser>
+        <c:axId val="-2068027336"/>
+        <c:axId val="-2113994440"/>
+      </c:barChart>
+      <c:catAx>
+        <c:axId val="-2068027336"/>
+        <c:scaling>
+          <c:orientation val="minMax"/>
+        </c:scaling>
+        <c:delete val="0"/>
+        <c:axPos val="l"/>
+        <c:majorTickMark val="out"/>
+        <c:minorTickMark val="none"/>
+        <c:tickLblPos val="nextTo"/>
+        <c:txPr>
+          <a:bodyPr/>
+          <a:lstStyle/>
+          <a:p>
+            <a:pPr>
+              <a:defRPr sz="1100">
+                <a:solidFill>
+                  <a:srgbClr val="A6B0BF"/>
+                </a:solidFill>
+                <a:latin typeface="Calibri"/>
+              </a:defRPr>
+            </a:pPr>
+          </a:p>
+        </c:txPr>
+        <c:crossAx val="-2113994440"/>
+        <c:crosses val="autoZero"/>
+        <c:auto val="1"/>
+        <c:lblAlgn val="ctr"/>
+        <c:lblOffset val="100"/>
+        <c:noMultiLvlLbl val="0"/>
+      </c:catAx>
+      <c:valAx>
+        <c:axId val="-2113994440"/>
+        <c:scaling>
+          <c:max val="100.0"/>
+        </c:scaling>
+        <c:delete val="0"/>
+        <c:axPos val="b"/>
+        <c:majorGridlines>
+          <c:spPr>
+            <a:ln>
+              <a:solidFill>
+                <a:srgbClr val="363F4F"/>
+              </a:solidFill>
+            </a:ln>
+          </c:spPr>
+        </c:majorGridlines>
+        <c:majorTickMark val="out"/>
+        <c:minorTickMark val="none"/>
+        <c:tickLblPos val="nextTo"/>
+        <c:txPr>
+          <a:bodyPr/>
+          <a:lstStyle/>
+          <a:p>
+            <a:pPr>
+              <a:defRPr sz="1100">
+                <a:solidFill>
+                  <a:srgbClr val="A6B0BF"/>
+                </a:solidFill>
+                <a:latin typeface="Calibri"/>
+              </a:defRPr>
+            </a:pPr>
+          </a:p>
+        </c:txPr>
+        <c:crossAx val="-2068027336"/>
+        <c:crosses val="autoZero"/>
+      </c:valAx>
+    </c:plotArea>
+    <c:dispBlanksAs val="gap"/>
+  </c:chart>
+  <c:txPr>
+    <a:bodyPr/>
+    <a:lstStyle/>
+    <a:p>
+      <a:pPr>
+        <a:defRPr sz="1800"/>
+      </a:pPr>
+      <a:endParaRPr lang="en-US"/>
+    </a:p>
+  </c:txPr>
+  <c:externalData r:id="rId1">
+    <c:autoUpdate val="0"/>
+  </c:externalData>
+</c:chartSpace>
+</file>
+
+<file path=ppt/charts/chart3.xml><?xml version="1.0" encoding="utf-8"?>
 <c:chartSpace xmlns:c="http://schemas.openxmlformats.org/drawingml/2006/chart" xmlns:a="http://schemas.openxmlformats.org/drawingml/2006/main" xmlns:r="http://schemas.openxmlformats.org/officeDocument/2006/relationships">
   <c:date1904 val="0"/>
   <c:chart>
@@ -446,7 +616,7 @@
 </c:chartSpace>
 </file>
 
-<file path=ppt/charts/chart3.xml><?xml version="1.0" encoding="utf-8"?>
+<file path=ppt/charts/chart4.xml><?xml version="1.0" encoding="utf-8"?>
 <c:chartSpace xmlns:c="http://schemas.openxmlformats.org/drawingml/2006/chart" xmlns:a="http://schemas.openxmlformats.org/drawingml/2006/main" xmlns:r="http://schemas.openxmlformats.org/officeDocument/2006/relationships">
   <c:date1904 val="0"/>
   <c:chart>
@@ -702,7 +872,7 @@
 </c:chartSpace>
 </file>
 
-<file path=ppt/charts/chart4.xml><?xml version="1.0" encoding="utf-8"?>
+<file path=ppt/charts/chart5.xml><?xml version="1.0" encoding="utf-8"?>
 <c:chartSpace xmlns:c="http://schemas.openxmlformats.org/drawingml/2006/chart" xmlns:a="http://schemas.openxmlformats.org/drawingml/2006/main" xmlns:r="http://schemas.openxmlformats.org/officeDocument/2006/relationships">
   <c:date1904 val="0"/>
   <c:chart>
@@ -927,7 +1097,7 @@
 </c:chartSpace>
 </file>
 
-<file path=ppt/charts/chart5.xml><?xml version="1.0" encoding="utf-8"?>
+<file path=ppt/charts/chart6.xml><?xml version="1.0" encoding="utf-8"?>
 <c:chartSpace xmlns:c="http://schemas.openxmlformats.org/drawingml/2006/chart" xmlns:a="http://schemas.openxmlformats.org/drawingml/2006/main" xmlns:r="http://schemas.openxmlformats.org/officeDocument/2006/relationships">
   <c:date1904 val="0"/>
   <c:chart>
@@ -4601,7 +4771,7 @@
                 </a:solidFill>
                 <a:latin typeface="Calibri"/>
               </a:rPr>
-              <a:t>Global Emotional Load</a:t>
+              <a:t>Global Emotional Landscape</a:t>
             </a:r>
           </a:p>
         </p:txBody>
@@ -4635,7 +4805,7 @@
                 </a:solidFill>
                 <a:latin typeface="Calibri"/>
               </a:rPr>
-              <a:t>Daily distress indicators remain elevated worldwide</a:t>
+              <a:t>Risk signals and capacity signals both matter</a:t>
             </a:r>
           </a:p>
         </p:txBody>
@@ -4649,7 +4819,7 @@
         <p:spPr>
           <a:xfrm>
             <a:off x="685800" y="1901952"/>
-            <a:ext cx="7360920" cy="4251960"/>
+            <a:ext cx="5486400" cy="4251960"/>
           </a:xfrm>
           <a:prstGeom prst="roundRect">
             <a:avLst/>
@@ -4694,8 +4864,8 @@
           <p:nvPr/>
         </p:nvGraphicFramePr>
         <p:xfrm>
-          <a:off x="960120" y="2240280"/>
-          <a:ext cx="6812280" cy="3611880"/>
+          <a:off x="914400" y="2331720"/>
+          <a:ext cx="5074920" cy="3520440"/>
         </p:xfrm>
         <a:graphic>
           <a:graphicData uri="http://schemas.openxmlformats.org/drawingml/2006/chart">
@@ -4711,8 +4881,8 @@
         </p:nvSpPr>
         <p:spPr>
           <a:xfrm>
-            <a:off x="8275320" y="1901952"/>
-            <a:ext cx="3246120" cy="4251960"/>
+            <a:off x="6355080" y="1901952"/>
+            <a:ext cx="5349240" cy="4251960"/>
           </a:xfrm>
           <a:prstGeom prst="roundRect">
             <a:avLst/>
@@ -4748,16 +4918,34 @@
           </a:p>
         </p:txBody>
       </p:sp>
-      <p:sp>
-        <p:nvSpPr>
-          <p:cNvPr id="10" name="TextBox 9"/>
+      <p:graphicFrame>
+        <p:nvGraphicFramePr>
+          <p:cNvPr id="10" name="Chart 9"/>
+          <p:cNvGraphicFramePr>
+            <a:graphicFrameLocks noGrp="1"/>
+          </p:cNvGraphicFramePr>
+          <p:nvPr/>
+        </p:nvGraphicFramePr>
+        <p:xfrm>
+          <a:off x="6583680" y="2331720"/>
+          <a:ext cx="4937760" cy="3520440"/>
+        </p:xfrm>
+        <a:graphic>
+          <a:graphicData uri="http://schemas.openxmlformats.org/drawingml/2006/chart">
+            <c:chart xmlns:c="http://schemas.openxmlformats.org/drawingml/2006/chart" r:id="rId3"/>
+          </a:graphicData>
+        </a:graphic>
+      </p:graphicFrame>
+      <p:sp>
+        <p:nvSpPr>
+          <p:cNvPr id="11" name="TextBox 10"/>
           <p:cNvSpPr txBox="1"/>
           <p:nvPr/>
         </p:nvSpPr>
         <p:spPr>
           <a:xfrm>
-            <a:off x="8549640" y="2240280"/>
-            <a:ext cx="2560320" cy="1463040"/>
+            <a:off x="685800" y="6464808"/>
+            <a:ext cx="10972800" cy="219456"/>
           </a:xfrm>
           <a:prstGeom prst="rect">
             <a:avLst/>
@@ -4770,155 +4958,14 @@
           </a:bodyPr>
           <a:lstStyle/>
           <a:p>
-            <a:pPr algn="l"/>
-            <a:r>
-              <a:rPr sz="1000">
+            <a:r>
+              <a:rPr sz="900">
                 <a:solidFill>
                   <a:srgbClr val="A6B0BF"/>
                 </a:solidFill>
                 <a:latin typeface="Consolas"/>
               </a:rPr>
-              <a:t>WORRY</a:t>
-            </a:r>
-          </a:p>
-          <a:p>
-            <a:pPr algn="l"/>
-            <a:r>
-              <a:rPr sz="3800" b="1">
-                <a:solidFill>
-                  <a:srgbClr val="D76060"/>
-                </a:solidFill>
-                <a:latin typeface="Calibri"/>
-              </a:rPr>
-              <a:t>39%</a:t>
-            </a:r>
-          </a:p>
-        </p:txBody>
-      </p:sp>
-      <p:sp>
-        <p:nvSpPr>
-          <p:cNvPr id="11" name="TextBox 10"/>
-          <p:cNvSpPr txBox="1"/>
-          <p:nvPr/>
-        </p:nvSpPr>
-        <p:spPr>
-          <a:xfrm>
-            <a:off x="8549640" y="3401568"/>
-            <a:ext cx="2560320" cy="1463040"/>
-          </a:xfrm>
-          <a:prstGeom prst="rect">
-            <a:avLst/>
-          </a:prstGeom>
-          <a:noFill/>
-        </p:spPr>
-        <p:txBody>
-          <a:bodyPr wrap="none">
-            <a:spAutoFit/>
-          </a:bodyPr>
-          <a:lstStyle/>
-          <a:p>
-            <a:pPr algn="l"/>
-            <a:r>
-              <a:rPr sz="1000">
-                <a:solidFill>
-                  <a:srgbClr val="A6B0BF"/>
-                </a:solidFill>
-                <a:latin typeface="Consolas"/>
-              </a:rPr>
-              <a:t>STRESS</a:t>
-            </a:r>
-          </a:p>
-          <a:p>
-            <a:pPr algn="l"/>
-            <a:r>
-              <a:rPr sz="3800" b="1">
-                <a:solidFill>
-                  <a:srgbClr val="EBAB4A"/>
-                </a:solidFill>
-                <a:latin typeface="Calibri"/>
-              </a:rPr>
-              <a:t>37%</a:t>
-            </a:r>
-          </a:p>
-        </p:txBody>
-      </p:sp>
-      <p:sp>
-        <p:nvSpPr>
-          <p:cNvPr id="12" name="TextBox 11"/>
-          <p:cNvSpPr txBox="1"/>
-          <p:nvPr/>
-        </p:nvSpPr>
-        <p:spPr>
-          <a:xfrm>
-            <a:off x="8549640" y="4562856"/>
-            <a:ext cx="2560320" cy="1463040"/>
-          </a:xfrm>
-          <a:prstGeom prst="rect">
-            <a:avLst/>
-          </a:prstGeom>
-          <a:noFill/>
-        </p:spPr>
-        <p:txBody>
-          <a:bodyPr wrap="none">
-            <a:spAutoFit/>
-          </a:bodyPr>
-          <a:lstStyle/>
-          <a:p>
-            <a:pPr algn="l"/>
-            <a:r>
-              <a:rPr sz="1000">
-                <a:solidFill>
-                  <a:srgbClr val="A6B0BF"/>
-                </a:solidFill>
-                <a:latin typeface="Consolas"/>
-              </a:rPr>
-              <a:t>PAIN</a:t>
-            </a:r>
-          </a:p>
-          <a:p>
-            <a:pPr algn="l"/>
-            <a:r>
-              <a:rPr sz="3800" b="1">
-                <a:solidFill>
-                  <a:srgbClr val="5E99F4"/>
-                </a:solidFill>
-                <a:latin typeface="Calibri"/>
-              </a:rPr>
-              <a:t>32%</a:t>
-            </a:r>
-          </a:p>
-        </p:txBody>
-      </p:sp>
-      <p:sp>
-        <p:nvSpPr>
-          <p:cNvPr id="13" name="TextBox 12"/>
-          <p:cNvSpPr txBox="1"/>
-          <p:nvPr/>
-        </p:nvSpPr>
-        <p:spPr>
-          <a:xfrm>
-            <a:off x="685800" y="6464808"/>
-            <a:ext cx="10972800" cy="219456"/>
-          </a:xfrm>
-          <a:prstGeom prst="rect">
-            <a:avLst/>
-          </a:prstGeom>
-          <a:noFill/>
-        </p:spPr>
-        <p:txBody>
-          <a:bodyPr wrap="none">
-            <a:spAutoFit/>
-          </a:bodyPr>
-          <a:lstStyle/>
-          <a:p>
-            <a:r>
-              <a:rPr sz="900">
-                <a:solidFill>
-                  <a:srgbClr val="A6B0BF"/>
-                </a:solidFill>
-                <a:latin typeface="Consolas"/>
-              </a:rPr>
-              <a:t>Source: Gallup State of the World's Emotional Health (2024 global survey)</a:t>
+              <a:t>Source: Gallup State of the World's Emotional Health (2024 global survey): negative + positive indicators</a:t>
             </a:r>
           </a:p>
         </p:txBody>

</xml_diff>

<commit_message>
Add narrative story arc and explainer text slides to deck
Co-authored-by: EmberEnterprises <EmberEnterprises@users.noreply.github.com>
</commit_message>
<xml_diff>
--- a/public/Stillform_Executive_Deck.pptx
+++ b/public/Stillform_Executive_Deck.pptx
@@ -133,7 +133,7 @@
               <c:strCache>
                 <c:ptCount val="1"/>
                 <c:pt idx="0">
-                  <c:v>Daily negative (%)</c:v>
+                  <c:v>Daily negative experiences (%)</c:v>
                 </c:pt>
               </c:strCache>
             </c:strRef>
@@ -142,11 +142,11 @@
             <c:idx val="0"/>
             <c:spPr>
               <a:solidFill>
-                <a:srgbClr val="C8922A"/>
+                <a:srgbClr val="967534"/>
               </a:solidFill>
               <a:ln>
                 <a:solidFill>
-                  <a:srgbClr val="C8922A"/>
+                  <a:srgbClr val="967534"/>
                 </a:solidFill>
               </a:ln>
             </c:spPr>
@@ -155,11 +155,11 @@
             <c:idx val="1"/>
             <c:spPr>
               <a:solidFill>
-                <a:srgbClr val="C8922A"/>
+                <a:srgbClr val="967534"/>
               </a:solidFill>
               <a:ln>
                 <a:solidFill>
-                  <a:srgbClr val="C8922A"/>
+                  <a:srgbClr val="967534"/>
                 </a:solidFill>
               </a:ln>
             </c:spPr>
@@ -168,11 +168,11 @@
             <c:idx val="2"/>
             <c:spPr>
               <a:solidFill>
-                <a:srgbClr val="C8922A"/>
+                <a:srgbClr val="967534"/>
               </a:solidFill>
               <a:ln>
                 <a:solidFill>
-                  <a:srgbClr val="C8922A"/>
+                  <a:srgbClr val="967534"/>
                 </a:solidFill>
               </a:ln>
             </c:spPr>
@@ -181,11 +181,11 @@
             <c:idx val="3"/>
             <c:spPr>
               <a:solidFill>
-                <a:srgbClr val="C8922A"/>
+                <a:srgbClr val="967534"/>
               </a:solidFill>
               <a:ln>
                 <a:solidFill>
-                  <a:srgbClr val="C8922A"/>
+                  <a:srgbClr val="967534"/>
                 </a:solidFill>
               </a:ln>
             </c:spPr>
@@ -194,11 +194,11 @@
             <c:idx val="4"/>
             <c:spPr>
               <a:solidFill>
-                <a:srgbClr val="C8922A"/>
+                <a:srgbClr val="967534"/>
               </a:solidFill>
               <a:ln>
                 <a:solidFill>
-                  <a:srgbClr val="C8922A"/>
+                  <a:srgbClr val="967534"/>
                 </a:solidFill>
               </a:ln>
             </c:spPr>
@@ -269,7 +269,7 @@
           <a:lstStyle/>
           <a:p>
             <a:pPr>
-              <a:defRPr sz="900">
+              <a:defRPr sz="1000">
                 <a:solidFill>
                   <a:srgbClr val="9496A1"/>
                 </a:solidFill>
@@ -296,7 +296,7 @@
           <c:spPr>
             <a:ln>
               <a:solidFill>
-                <a:srgbClr val="3D3E47"/>
+                <a:srgbClr val="3A3A42"/>
               </a:solidFill>
             </a:ln>
           </c:spPr>
@@ -309,7 +309,7 @@
           <a:lstStyle/>
           <a:p>
             <a:pPr>
-              <a:defRPr sz="900">
+              <a:defRPr sz="1000">
                 <a:solidFill>
                   <a:srgbClr val="9496A1"/>
                 </a:solidFill>
@@ -358,7 +358,7 @@
               <c:strCache>
                 <c:ptCount val="1"/>
                 <c:pt idx="0">
-                  <c:v>Daily positive (%)</c:v>
+                  <c:v>Daily positive experiences (%)</c:v>
                 </c:pt>
               </c:strCache>
             </c:strRef>
@@ -367,11 +367,11 @@
             <c:idx val="0"/>
             <c:spPr>
               <a:solidFill>
-                <a:srgbClr val="777D8C"/>
+                <a:srgbClr val="6A81AA"/>
               </a:solidFill>
               <a:ln>
                 <a:solidFill>
-                  <a:srgbClr val="777D8C"/>
+                  <a:srgbClr val="6A81AA"/>
                 </a:solidFill>
               </a:ln>
             </c:spPr>
@@ -380,11 +380,11 @@
             <c:idx val="1"/>
             <c:spPr>
               <a:solidFill>
-                <a:srgbClr val="777D8C"/>
+                <a:srgbClr val="6A81AA"/>
               </a:solidFill>
               <a:ln>
                 <a:solidFill>
-                  <a:srgbClr val="777D8C"/>
+                  <a:srgbClr val="6A81AA"/>
                 </a:solidFill>
               </a:ln>
             </c:spPr>
@@ -393,11 +393,11 @@
             <c:idx val="2"/>
             <c:spPr>
               <a:solidFill>
-                <a:srgbClr val="777D8C"/>
+                <a:srgbClr val="6A81AA"/>
               </a:solidFill>
               <a:ln>
                 <a:solidFill>
-                  <a:srgbClr val="777D8C"/>
+                  <a:srgbClr val="6A81AA"/>
                 </a:solidFill>
               </a:ln>
             </c:spPr>
@@ -406,11 +406,11 @@
             <c:idx val="3"/>
             <c:spPr>
               <a:solidFill>
-                <a:srgbClr val="777D8C"/>
+                <a:srgbClr val="6A81AA"/>
               </a:solidFill>
               <a:ln>
                 <a:solidFill>
-                  <a:srgbClr val="777D8C"/>
+                  <a:srgbClr val="6A81AA"/>
                 </a:solidFill>
               </a:ln>
             </c:spPr>
@@ -419,11 +419,11 @@
             <c:idx val="4"/>
             <c:spPr>
               <a:solidFill>
-                <a:srgbClr val="777D8C"/>
+                <a:srgbClr val="6A81AA"/>
               </a:solidFill>
               <a:ln>
                 <a:solidFill>
-                  <a:srgbClr val="777D8C"/>
+                  <a:srgbClr val="6A81AA"/>
                 </a:solidFill>
               </a:ln>
             </c:spPr>
@@ -437,10 +437,10 @@
                   <c:v>Respect</c:v>
                 </c:pt>
                 <c:pt idx="1">
-                  <c:v>Enjoyment</c:v>
+                  <c:v>Laughter</c:v>
                 </c:pt>
                 <c:pt idx="2">
-                  <c:v>Laughter</c:v>
+                  <c:v>Enjoyment</c:v>
                 </c:pt>
                 <c:pt idx="3">
                   <c:v>Rested</c:v>
@@ -494,7 +494,7 @@
           <a:lstStyle/>
           <a:p>
             <a:pPr>
-              <a:defRPr sz="900">
+              <a:defRPr sz="1000">
                 <a:solidFill>
                   <a:srgbClr val="9496A1"/>
                 </a:solidFill>
@@ -521,7 +521,7 @@
           <c:spPr>
             <a:ln>
               <a:solidFill>
-                <a:srgbClr val="3D3E47"/>
+                <a:srgbClr val="3A3A42"/>
               </a:solidFill>
             </a:ln>
           </c:spPr>
@@ -534,7 +534,7 @@
           <a:lstStyle/>
           <a:p>
             <a:pPr>
-              <a:defRPr sz="900">
+              <a:defRPr sz="1000">
                 <a:solidFill>
                   <a:srgbClr val="9496A1"/>
                 </a:solidFill>
@@ -583,7 +583,7 @@
               <c:strCache>
                 <c:ptCount val="1"/>
                 <c:pt idx="0">
-                  <c:v>Index</c:v>
+                  <c:v>Issue/lever index</c:v>
                 </c:pt>
               </c:strCache>
             </c:strRef>
@@ -592,11 +592,11 @@
             <c:idx val="0"/>
             <c:spPr>
               <a:solidFill>
-                <a:srgbClr val="C8922A"/>
+                <a:srgbClr val="967534"/>
               </a:solidFill>
               <a:ln>
                 <a:solidFill>
-                  <a:srgbClr val="C8922A"/>
+                  <a:srgbClr val="967534"/>
                 </a:solidFill>
               </a:ln>
             </c:spPr>
@@ -605,11 +605,11 @@
             <c:idx val="1"/>
             <c:spPr>
               <a:solidFill>
-                <a:srgbClr val="C8922A"/>
+                <a:srgbClr val="967534"/>
               </a:solidFill>
               <a:ln>
                 <a:solidFill>
-                  <a:srgbClr val="C8922A"/>
+                  <a:srgbClr val="967534"/>
                 </a:solidFill>
               </a:ln>
             </c:spPr>
@@ -618,11 +618,11 @@
             <c:idx val="2"/>
             <c:spPr>
               <a:solidFill>
-                <a:srgbClr val="C8922A"/>
+                <a:srgbClr val="6A81AA"/>
               </a:solidFill>
               <a:ln>
                 <a:solidFill>
-                  <a:srgbClr val="C8922A"/>
+                  <a:srgbClr val="6A81AA"/>
                 </a:solidFill>
               </a:ln>
             </c:spPr>
@@ -631,11 +631,11 @@
             <c:idx val="3"/>
             <c:spPr>
               <a:solidFill>
-                <a:srgbClr val="C8922A"/>
+                <a:srgbClr val="7EA27E"/>
               </a:solidFill>
               <a:ln>
                 <a:solidFill>
-                  <a:srgbClr val="C8922A"/>
+                  <a:srgbClr val="7EA27E"/>
                 </a:solidFill>
               </a:ln>
             </c:spPr>
@@ -655,7 +655,7 @@
                   <c:v>Learning signal</c:v>
                 </c:pt>
                 <c:pt idx="3">
-                  <c:v>Affect-label support</c:v>
+                  <c:v>Affect-label lever</c:v>
                 </c:pt>
               </c:strCache>
             </c:strRef>
@@ -700,7 +700,7 @@
           <a:lstStyle/>
           <a:p>
             <a:pPr>
-              <a:defRPr sz="900">
+              <a:defRPr sz="1000">
                 <a:solidFill>
                   <a:srgbClr val="9496A1"/>
                 </a:solidFill>
@@ -727,7 +727,7 @@
           <c:spPr>
             <a:ln>
               <a:solidFill>
-                <a:srgbClr val="3D3E47"/>
+                <a:srgbClr val="3A3A42"/>
               </a:solidFill>
             </a:ln>
           </c:spPr>
@@ -740,7 +740,7 @@
           <a:lstStyle/>
           <a:p>
             <a:pPr>
-              <a:defRPr sz="900">
+              <a:defRPr sz="1000">
                 <a:solidFill>
                   <a:srgbClr val="9496A1"/>
                 </a:solidFill>
@@ -798,11 +798,11 @@
             <c:idx val="0"/>
             <c:spPr>
               <a:solidFill>
-                <a:srgbClr val="C8922A"/>
+                <a:srgbClr val="6A81AA"/>
               </a:solidFill>
               <a:ln>
                 <a:solidFill>
-                  <a:srgbClr val="C8922A"/>
+                  <a:srgbClr val="6A81AA"/>
                 </a:solidFill>
               </a:ln>
             </c:spPr>
@@ -811,11 +811,11 @@
             <c:idx val="1"/>
             <c:spPr>
               <a:solidFill>
-                <a:srgbClr val="C8922A"/>
+                <a:srgbClr val="6A81AA"/>
               </a:solidFill>
               <a:ln>
                 <a:solidFill>
-                  <a:srgbClr val="C8922A"/>
+                  <a:srgbClr val="6A81AA"/>
                 </a:solidFill>
               </a:ln>
             </c:spPr>
@@ -824,11 +824,11 @@
             <c:idx val="2"/>
             <c:spPr>
               <a:solidFill>
-                <a:srgbClr val="C8922A"/>
+                <a:srgbClr val="967534"/>
               </a:solidFill>
               <a:ln>
                 <a:solidFill>
-                  <a:srgbClr val="C8922A"/>
+                  <a:srgbClr val="967534"/>
                 </a:solidFill>
               </a:ln>
             </c:spPr>
@@ -837,11 +837,11 @@
             <c:idx val="3"/>
             <c:spPr>
               <a:solidFill>
-                <a:srgbClr val="C8922A"/>
+                <a:srgbClr val="967534"/>
               </a:solidFill>
               <a:ln>
                 <a:solidFill>
-                  <a:srgbClr val="C8922A"/>
+                  <a:srgbClr val="967534"/>
                 </a:solidFill>
               </a:ln>
             </c:spPr>
@@ -906,7 +906,7 @@
           <a:lstStyle/>
           <a:p>
             <a:pPr>
-              <a:defRPr sz="900">
+              <a:defRPr sz="1000">
                 <a:solidFill>
                   <a:srgbClr val="9496A1"/>
                 </a:solidFill>
@@ -933,7 +933,7 @@
           <c:spPr>
             <a:ln>
               <a:solidFill>
-                <a:srgbClr val="3D3E47"/>
+                <a:srgbClr val="3A3A42"/>
               </a:solidFill>
             </a:ln>
           </c:spPr>
@@ -946,7 +946,7 @@
           <a:lstStyle/>
           <a:p>
             <a:pPr>
-              <a:defRPr sz="900">
+              <a:defRPr sz="1000">
                 <a:solidFill>
                   <a:srgbClr val="9496A1"/>
                 </a:solidFill>
@@ -995,7 +995,7 @@
               <c:strCache>
                 <c:ptCount val="1"/>
                 <c:pt idx="0">
-                  <c:v>Unrest index</c:v>
+                  <c:v>Riots/strikes/anti-gov demos index</c:v>
                 </c:pt>
               </c:strCache>
             </c:strRef>
@@ -1004,11 +1004,11 @@
             <c:idx val="0"/>
             <c:spPr>
               <a:solidFill>
-                <a:srgbClr val="C8922A"/>
+                <a:srgbClr val="967534"/>
               </a:solidFill>
               <a:ln>
                 <a:solidFill>
-                  <a:srgbClr val="C8922A"/>
+                  <a:srgbClr val="967534"/>
                 </a:solidFill>
               </a:ln>
             </c:spPr>
@@ -1017,11 +1017,11 @@
             <c:idx val="1"/>
             <c:spPr>
               <a:solidFill>
-                <a:srgbClr val="C8922A"/>
+                <a:srgbClr val="967534"/>
               </a:solidFill>
               <a:ln>
                 <a:solidFill>
-                  <a:srgbClr val="C8922A"/>
+                  <a:srgbClr val="967534"/>
                 </a:solidFill>
               </a:ln>
             </c:spPr>
@@ -1032,10 +1032,10 @@
               <c:strCache>
                 <c:ptCount val="2"/>
                 <c:pt idx="0">
-                  <c:v>2011</c:v>
+                  <c:v>2011 baseline</c:v>
                 </c:pt>
                 <c:pt idx="1">
-                  <c:v>2019</c:v>
+                  <c:v>2019 level</c:v>
                 </c:pt>
               </c:strCache>
             </c:strRef>
@@ -1074,7 +1074,7 @@
           <a:lstStyle/>
           <a:p>
             <a:pPr>
-              <a:defRPr sz="900">
+              <a:defRPr sz="1000">
                 <a:solidFill>
                   <a:srgbClr val="9496A1"/>
                 </a:solidFill>
@@ -1101,7 +1101,7 @@
           <c:spPr>
             <a:ln>
               <a:solidFill>
-                <a:srgbClr val="3D3E47"/>
+                <a:srgbClr val="3A3A42"/>
               </a:solidFill>
             </a:ln>
           </c:spPr>
@@ -1114,7 +1114,7 @@
           <a:lstStyle/>
           <a:p>
             <a:pPr>
-              <a:defRPr sz="900">
+              <a:defRPr sz="1000">
                 <a:solidFill>
                   <a:srgbClr val="9496A1"/>
                 </a:solidFill>
@@ -1163,7 +1163,7 @@
               <c:strCache>
                 <c:ptCount val="1"/>
                 <c:pt idx="0">
-                  <c:v>Daily pressure (%)</c:v>
+                  <c:v>Daily pressure prevalence (%)</c:v>
                 </c:pt>
               </c:strCache>
             </c:strRef>
@@ -1172,11 +1172,11 @@
             <c:idx val="0"/>
             <c:spPr>
               <a:solidFill>
-                <a:srgbClr val="777D8C"/>
+                <a:srgbClr val="6A81AA"/>
               </a:solidFill>
               <a:ln>
                 <a:solidFill>
-                  <a:srgbClr val="777D8C"/>
+                  <a:srgbClr val="6A81AA"/>
                 </a:solidFill>
               </a:ln>
             </c:spPr>
@@ -1185,11 +1185,11 @@
             <c:idx val="1"/>
             <c:spPr>
               <a:solidFill>
-                <a:srgbClr val="777D8C"/>
+                <a:srgbClr val="6A81AA"/>
               </a:solidFill>
               <a:ln>
                 <a:solidFill>
-                  <a:srgbClr val="777D8C"/>
+                  <a:srgbClr val="6A81AA"/>
                 </a:solidFill>
               </a:ln>
             </c:spPr>
@@ -1242,7 +1242,7 @@
           <a:lstStyle/>
           <a:p>
             <a:pPr>
-              <a:defRPr sz="900">
+              <a:defRPr sz="1000">
                 <a:solidFill>
                   <a:srgbClr val="9496A1"/>
                 </a:solidFill>
@@ -1269,7 +1269,7 @@
           <c:spPr>
             <a:ln>
               <a:solidFill>
-                <a:srgbClr val="3D3E47"/>
+                <a:srgbClr val="3A3A42"/>
               </a:solidFill>
             </a:ln>
           </c:spPr>
@@ -1282,7 +1282,7 @@
           <a:lstStyle/>
           <a:p>
             <a:pPr>
-              <a:defRPr sz="900">
+              <a:defRPr sz="1000">
                 <a:solidFill>
                   <a:srgbClr val="9496A1"/>
                 </a:solidFill>
@@ -1331,7 +1331,7 @@
               <c:strCache>
                 <c:ptCount val="1"/>
                 <c:pt idx="0">
-                  <c:v>Instrumentation coverage</c:v>
+                  <c:v>Signal coverage index</c:v>
                 </c:pt>
               </c:strCache>
             </c:strRef>
@@ -1407,7 +1407,7 @@
               <c:strCache>
                 <c:ptCount val="5"/>
                 <c:pt idx="0">
-                  <c:v>Pre/post shift</c:v>
+                  <c:v>Pre/post delta</c:v>
                 </c:pt>
                 <c:pt idx="1">
                   <c:v>Loop completion 14d</c:v>
@@ -1467,7 +1467,7 @@
           <a:lstStyle/>
           <a:p>
             <a:pPr>
-              <a:defRPr sz="900">
+              <a:defRPr sz="1000">
                 <a:solidFill>
                   <a:srgbClr val="9496A1"/>
                 </a:solidFill>
@@ -1494,7 +1494,7 @@
           <c:spPr>
             <a:ln>
               <a:solidFill>
-                <a:srgbClr val="3D3E47"/>
+                <a:srgbClr val="3A3A42"/>
               </a:solidFill>
             </a:ln>
           </c:spPr>
@@ -1507,7 +1507,7 @@
           <a:lstStyle/>
           <a:p>
             <a:pPr>
-              <a:defRPr sz="900">
+              <a:defRPr sz="1000">
                 <a:solidFill>
                   <a:srgbClr val="9496A1"/>
                 </a:solidFill>
@@ -4579,7 +4579,7 @@
         <p:spPr>
           <a:xfrm>
             <a:off x="502920" y="100584"/>
-            <a:ext cx="7315200" cy="182880"/>
+            <a:ext cx="7772400" cy="182880"/>
           </a:xfrm>
           <a:prstGeom prst="rect">
             <a:avLst/>
@@ -4593,13 +4593,13 @@
           <a:lstStyle/>
           <a:p>
             <a:r>
-              <a:rPr sz="850">
+              <a:rPr sz="900">
                 <a:solidFill>
                   <a:srgbClr val="C8922A"/>
                 </a:solidFill>
                 <a:latin typeface="Consolas"/>
               </a:rPr>
-              <a:t>STILLFORM · APPLIED SCIENCE BRIEF</a:t>
+              <a:t>STILLFORM · EXECUTIVE APPLIED SCIENCE BRIEF</a:t>
             </a:r>
           </a:p>
         </p:txBody>
@@ -4612,8 +4612,8 @@
         </p:nvSpPr>
         <p:spPr>
           <a:xfrm>
-            <a:off x="10149840" y="100584"/>
-            <a:ext cx="1554480" cy="182880"/>
+            <a:off x="10241280" y="100584"/>
+            <a:ext cx="1463040" cy="182880"/>
           </a:xfrm>
           <a:prstGeom prst="rect">
             <a:avLst/>
@@ -4628,7 +4628,7 @@
           <a:p>
             <a:pPr algn="r"/>
             <a:r>
-              <a:rPr sz="850">
+              <a:rPr sz="900">
                 <a:solidFill>
                   <a:srgbClr val="9496A1"/>
                 </a:solidFill>
@@ -4648,7 +4648,7 @@
         <p:spPr>
           <a:xfrm>
             <a:off x="640080" y="640080"/>
-            <a:ext cx="10972800" cy="1005840"/>
+            <a:ext cx="10972800" cy="960120"/>
           </a:xfrm>
           <a:prstGeom prst="rect">
             <a:avLst/>
@@ -4662,13 +4662,13 @@
           <a:lstStyle/>
           <a:p>
             <a:r>
-              <a:rPr sz="3600" b="1">
+              <a:rPr sz="3800" b="1">
                 <a:solidFill>
                   <a:srgbClr val="E8EAF0"/>
                 </a:solidFill>
                 <a:latin typeface="Calibri"/>
               </a:rPr>
-              <a:t>Stillform: Applied Science</a:t>
+              <a:t>What Stillform Is</a:t>
             </a:r>
           </a:p>
         </p:txBody>
@@ -4681,8 +4681,8 @@
         </p:nvSpPr>
         <p:spPr>
           <a:xfrm>
-            <a:off x="658368" y="1417320"/>
-            <a:ext cx="10972800" cy="365760"/>
+            <a:off x="676656" y="1417320"/>
+            <a:ext cx="10881360" cy="411480"/>
           </a:xfrm>
           <a:prstGeom prst="rect">
             <a:avLst/>
@@ -4696,13 +4696,13 @@
           <a:lstStyle/>
           <a:p>
             <a:r>
-              <a:rPr sz="1400">
+              <a:rPr sz="1500">
                 <a:solidFill>
                   <a:srgbClr val="9496A1"/>
                 </a:solidFill>
                 <a:latin typeface="Calibri"/>
               </a:rPr>
-              <a:t>Executive view — mechanism, not marketing</a:t>
+              <a:t>The story anchor before any charts</a:t>
             </a:r>
           </a:p>
         </p:txBody>
@@ -4715,8 +4715,8 @@
         </p:nvSpPr>
         <p:spPr>
           <a:xfrm>
-            <a:off x="777240" y="2011680"/>
-            <a:ext cx="10881360" cy="3749039"/>
+            <a:off x="777240" y="1920240"/>
+            <a:ext cx="10881360" cy="4343400"/>
           </a:xfrm>
           <a:prstGeom prst="rect">
             <a:avLst/>
@@ -4724,9 +4724,9 @@
           <a:solidFill>
             <a:srgbClr val="141418"/>
           </a:solidFill>
-          <a:ln w="11430">
+          <a:ln w="12700">
             <a:solidFill>
-              <a:srgbClr val="3D3E47"/>
+              <a:srgbClr val="3A3A42"/>
             </a:solidFill>
           </a:ln>
         </p:spPr>
@@ -4760,8 +4760,8 @@
         </p:nvSpPr>
         <p:spPr>
           <a:xfrm>
-            <a:off x="1051560" y="2423160"/>
-            <a:ext cx="10241280" cy="3108960"/>
+            <a:off x="1051560" y="2240280"/>
+            <a:ext cx="10241280" cy="3566160"/>
           </a:xfrm>
           <a:prstGeom prst="rect">
             <a:avLst/>
@@ -4769,16 +4769,16 @@
           <a:noFill/>
         </p:spPr>
         <p:txBody>
-          <a:bodyPr wrap="none">
+          <a:bodyPr wrap="square">
             <a:spAutoFit/>
           </a:bodyPr>
           <a:lstStyle/>
           <a:p>
             <a:pPr>
               <a:spcAft>
-                <a:spcPts val="800"/>
+                <a:spcPts val="900"/>
               </a:spcAft>
-              <a:defRPr sz="2000">
+              <a:defRPr sz="2200" b="1">
                 <a:solidFill>
                   <a:srgbClr val="E8EAF0"/>
                 </a:solidFill>
@@ -4786,15 +4786,15 @@
               </a:defRPr>
             </a:pPr>
             <a:r>
-              <a:t>Composure is treated as a trainable operational skill.</a:t>
+              <a:t>Stillform is a composure and self-awareness system.</a:t>
             </a:r>
           </a:p>
           <a:p>
             <a:pPr>
               <a:spcAft>
-                <a:spcPts val="800"/>
+                <a:spcPts val="700"/>
               </a:spcAft>
-              <a:defRPr sz="2000">
+              <a:defRPr sz="1600" b="0">
                 <a:solidFill>
                   <a:srgbClr val="E8EAF0"/>
                 </a:solidFill>
@@ -4802,15 +4802,15 @@
               </a:defRPr>
             </a:pPr>
             <a:r>
-              <a:t>Science domains: metacognition, EQ, impulsivity interruption, microbias conflict correction.</a:t>
+              <a:t>It is not a psychiatry app and not therapy replacement software.</a:t>
             </a:r>
           </a:p>
           <a:p>
             <a:pPr>
               <a:spcAft>
-                <a:spcPts val="800"/>
+                <a:spcPts val="700"/>
               </a:spcAft>
-              <a:defRPr sz="2000">
+              <a:defRPr sz="1600" b="0">
                 <a:solidFill>
                   <a:srgbClr val="E8EAF0"/>
                 </a:solidFill>
@@ -4818,7 +4818,23 @@
               </a:defRPr>
             </a:pPr>
             <a:r>
-              <a:t>Every chart maps to a Stillform mechanism and a measurable telemetry output.</a:t>
+              <a:t>It trains people to read state accurately, interrupt impulsive reactions, and choose better actions under load.</a:t>
+            </a:r>
+          </a:p>
+          <a:p>
+            <a:pPr>
+              <a:spcAft>
+                <a:spcPts val="700"/>
+              </a:spcAft>
+              <a:defRPr sz="1600" b="0">
+                <a:solidFill>
+                  <a:srgbClr val="E8EAF0"/>
+                </a:solidFill>
+                <a:latin typeface="Calibri"/>
+              </a:defRPr>
+            </a:pPr>
+            <a:r>
+              <a:t>Its core mechanism is daily loop execution: morning baseline -&gt; state-aware intervention -&gt; post-shift rating -&gt; evening closure.</a:t>
             </a:r>
           </a:p>
         </p:txBody>
@@ -4832,7 +4848,7 @@
         <p:spPr>
           <a:xfrm>
             <a:off x="685800" y="6428232"/>
-            <a:ext cx="10972800" cy="228600"/>
+            <a:ext cx="10972800" cy="219456"/>
           </a:xfrm>
           <a:prstGeom prst="rect">
             <a:avLst/>
@@ -4846,13 +4862,13 @@
           <a:lstStyle/>
           <a:p>
             <a:r>
-              <a:rPr sz="800">
+              <a:rPr sz="850">
                 <a:solidFill>
                   <a:srgbClr val="9496A1"/>
                 </a:solidFill>
                 <a:latin typeface="Consolas"/>
               </a:rPr>
-              <a:t>Source: Stillform science sheet + App.jsx telemetry model</a:t>
+              <a:t>Source: Stillform product architecture and privacy/disclaimer copy</a:t>
             </a:r>
           </a:p>
         </p:txBody>
@@ -4935,7 +4951,7 @@
         <p:spPr>
           <a:xfrm>
             <a:off x="502920" y="100584"/>
-            <a:ext cx="7315200" cy="182880"/>
+            <a:ext cx="7772400" cy="182880"/>
           </a:xfrm>
           <a:prstGeom prst="rect">
             <a:avLst/>
@@ -4949,13 +4965,13 @@
           <a:lstStyle/>
           <a:p>
             <a:r>
-              <a:rPr sz="850">
+              <a:rPr sz="900">
                 <a:solidFill>
                   <a:srgbClr val="C8922A"/>
                 </a:solidFill>
                 <a:latin typeface="Consolas"/>
               </a:rPr>
-              <a:t>STILLFORM · APPLIED SCIENCE BRIEF</a:t>
+              <a:t>STILLFORM · EXECUTIVE APPLIED SCIENCE BRIEF</a:t>
             </a:r>
           </a:p>
         </p:txBody>
@@ -4968,8 +4984,8 @@
         </p:nvSpPr>
         <p:spPr>
           <a:xfrm>
-            <a:off x="10149840" y="100584"/>
-            <a:ext cx="1554480" cy="182880"/>
+            <a:off x="10241280" y="100584"/>
+            <a:ext cx="1463040" cy="182880"/>
           </a:xfrm>
           <a:prstGeom prst="rect">
             <a:avLst/>
@@ -4984,7 +5000,7 @@
           <a:p>
             <a:pPr algn="r"/>
             <a:r>
-              <a:rPr sz="850">
+              <a:rPr sz="900">
                 <a:solidFill>
                   <a:srgbClr val="9496A1"/>
                 </a:solidFill>
@@ -5004,7 +5020,7 @@
         <p:spPr>
           <a:xfrm>
             <a:off x="640080" y="640080"/>
-            <a:ext cx="10972800" cy="1005840"/>
+            <a:ext cx="10972800" cy="960120"/>
           </a:xfrm>
           <a:prstGeom prst="rect">
             <a:avLst/>
@@ -5018,13 +5034,13 @@
           <a:lstStyle/>
           <a:p>
             <a:r>
-              <a:rPr sz="3600" b="1">
+              <a:rPr sz="3800" b="1">
                 <a:solidFill>
                   <a:srgbClr val="E8EAF0"/>
                 </a:solidFill>
                 <a:latin typeface="Calibri"/>
               </a:rPr>
-              <a:t>Global Context</a:t>
+              <a:t>Why These Visuals Matter</a:t>
             </a:r>
           </a:p>
         </p:txBody>
@@ -5037,8 +5053,8 @@
         </p:nvSpPr>
         <p:spPr>
           <a:xfrm>
-            <a:off x="658368" y="1417320"/>
-            <a:ext cx="10972800" cy="365760"/>
+            <a:off x="676656" y="1417320"/>
+            <a:ext cx="10881360" cy="411480"/>
           </a:xfrm>
           <a:prstGeom prst="rect">
             <a:avLst/>
@@ -5052,13 +5068,13 @@
           <a:lstStyle/>
           <a:p>
             <a:r>
-              <a:rPr sz="1400">
+              <a:rPr sz="1500">
                 <a:solidFill>
                   <a:srgbClr val="9496A1"/>
                 </a:solidFill>
                 <a:latin typeface="Calibri"/>
               </a:rPr>
-              <a:t>Pressure remains high; composure capacity is uneven</a:t>
+              <a:t>Each chart answers an executive decision question</a:t>
             </a:r>
           </a:p>
         </p:txBody>
@@ -5072,7 +5088,7 @@
         <p:spPr>
           <a:xfrm>
             <a:off x="685800" y="1874519"/>
-            <a:ext cx="5440680" cy="4297680"/>
+            <a:ext cx="11064240" cy="4389120"/>
           </a:xfrm>
           <a:prstGeom prst="rect">
             <a:avLst/>
@@ -5080,9 +5096,9 @@
           <a:solidFill>
             <a:srgbClr val="141418"/>
           </a:solidFill>
-          <a:ln w="11430">
+          <a:ln w="12700">
             <a:solidFill>
-              <a:srgbClr val="3D3E47"/>
+              <a:srgbClr val="3A3A42"/>
             </a:solidFill>
           </a:ln>
         </p:spPr>
@@ -5110,95 +5126,449 @@
       </p:sp>
       <p:graphicFrame>
         <p:nvGraphicFramePr>
-          <p:cNvPr id="8" name="Chart 7"/>
+          <p:cNvPr id="8" name="Table 7"/>
           <p:cNvGraphicFramePr>
             <a:graphicFrameLocks noGrp="1"/>
           </p:cNvGraphicFramePr>
           <p:nvPr/>
         </p:nvGraphicFramePr>
         <p:xfrm>
-          <a:off x="914400" y="2240280"/>
-          <a:ext cx="4983480" cy="3611880"/>
+          <a:off x="914400" y="2148840"/>
+          <a:ext cx="10607039" cy="3840480"/>
         </p:xfrm>
         <a:graphic>
-          <a:graphicData uri="http://schemas.openxmlformats.org/drawingml/2006/chart">
-            <c:chart xmlns:c="http://schemas.openxmlformats.org/drawingml/2006/chart" r:id="rId2"/>
+          <a:graphicData uri="http://schemas.openxmlformats.org/drawingml/2006/table">
+            <a:tbl>
+              <a:tblPr firstRow="1" bandRow="1">
+                <a:tableStyleId>{5C22544A-7EE6-4342-B048-85BDC9FD1C3A}</a:tableStyleId>
+              </a:tblPr>
+              <a:tblGrid>
+                <a:gridCol w="2560320"/>
+                <a:gridCol w="3749039"/>
+                <a:gridCol w="4297680"/>
+              </a:tblGrid>
+              <a:tr h="640080">
+                <a:tc>
+                  <a:txBody>
+                    <a:bodyPr/>
+                    <a:lstStyle/>
+                    <a:p>
+                      <a:r>
+                        <a:rPr sz="1100" b="1">
+                          <a:solidFill>
+                            <a:srgbClr val="C8922A"/>
+                          </a:solidFill>
+                          <a:latin typeface="Calibri"/>
+                        </a:rPr>
+                        <a:t>Visual</a:t>
+                      </a:r>
+                    </a:p>
+                  </a:txBody>
+                  <a:tcPr>
+                    <a:solidFill>
+                      <a:srgbClr val="141418"/>
+                    </a:solidFill>
+                  </a:tcPr>
+                </a:tc>
+                <a:tc>
+                  <a:txBody>
+                    <a:bodyPr/>
+                    <a:lstStyle/>
+                    <a:p>
+                      <a:r>
+                        <a:rPr sz="1100" b="1">
+                          <a:solidFill>
+                            <a:srgbClr val="C8922A"/>
+                          </a:solidFill>
+                          <a:latin typeface="Calibri"/>
+                        </a:rPr>
+                        <a:t>Question</a:t>
+                      </a:r>
+                    </a:p>
+                  </a:txBody>
+                  <a:tcPr>
+                    <a:solidFill>
+                      <a:srgbClr val="141418"/>
+                    </a:solidFill>
+                  </a:tcPr>
+                </a:tc>
+                <a:tc>
+                  <a:txBody>
+                    <a:bodyPr/>
+                    <a:lstStyle/>
+                    <a:p>
+                      <a:r>
+                        <a:rPr sz="1100" b="1">
+                          <a:solidFill>
+                            <a:srgbClr val="C8922A"/>
+                          </a:solidFill>
+                          <a:latin typeface="Calibri"/>
+                        </a:rPr>
+                        <a:t>Why it matters</a:t>
+                      </a:r>
+                    </a:p>
+                  </a:txBody>
+                  <a:tcPr>
+                    <a:solidFill>
+                      <a:srgbClr val="141418"/>
+                    </a:solidFill>
+                  </a:tcPr>
+                </a:tc>
+              </a:tr>
+              <a:tr h="640080">
+                <a:tc>
+                  <a:txBody>
+                    <a:bodyPr/>
+                    <a:lstStyle/>
+                    <a:p>
+                      <a:r>
+                        <a:rPr sz="1000" b="0">
+                          <a:solidFill>
+                            <a:srgbClr val="E8EAF0"/>
+                          </a:solidFill>
+                          <a:latin typeface="Calibri"/>
+                        </a:rPr>
+                        <a:t>Global context</a:t>
+                      </a:r>
+                    </a:p>
+                  </a:txBody>
+                  <a:tcPr>
+                    <a:solidFill>
+                      <a:srgbClr val="0A0A0C"/>
+                    </a:solidFill>
+                  </a:tcPr>
+                </a:tc>
+                <a:tc>
+                  <a:txBody>
+                    <a:bodyPr/>
+                    <a:lstStyle/>
+                    <a:p>
+                      <a:r>
+                        <a:rPr sz="1000" b="0">
+                          <a:solidFill>
+                            <a:srgbClr val="E8EAF0"/>
+                          </a:solidFill>
+                          <a:latin typeface="Calibri"/>
+                        </a:rPr>
+                        <a:t>Is composure demand real?</a:t>
+                      </a:r>
+                    </a:p>
+                  </a:txBody>
+                  <a:tcPr>
+                    <a:solidFill>
+                      <a:srgbClr val="0A0A0C"/>
+                    </a:solidFill>
+                  </a:tcPr>
+                </a:tc>
+                <a:tc>
+                  <a:txBody>
+                    <a:bodyPr/>
+                    <a:lstStyle/>
+                    <a:p>
+                      <a:r>
+                        <a:rPr sz="1000" b="0">
+                          <a:solidFill>
+                            <a:srgbClr val="E8EAF0"/>
+                          </a:solidFill>
+                          <a:latin typeface="Calibri"/>
+                        </a:rPr>
+                        <a:t>Shows pressure environment users live in.</a:t>
+                      </a:r>
+                    </a:p>
+                  </a:txBody>
+                  <a:tcPr>
+                    <a:solidFill>
+                      <a:srgbClr val="0A0A0C"/>
+                    </a:solidFill>
+                  </a:tcPr>
+                </a:tc>
+              </a:tr>
+              <a:tr h="640080">
+                <a:tc>
+                  <a:txBody>
+                    <a:bodyPr/>
+                    <a:lstStyle/>
+                    <a:p>
+                      <a:r>
+                        <a:rPr sz="1000" b="0">
+                          <a:solidFill>
+                            <a:srgbClr val="E8EAF0"/>
+                          </a:solidFill>
+                          <a:latin typeface="Calibri"/>
+                        </a:rPr>
+                        <a:t>Metacognition</a:t>
+                      </a:r>
+                    </a:p>
+                  </a:txBody>
+                  <a:tcPr>
+                    <a:solidFill>
+                      <a:srgbClr val="1A1A1F"/>
+                    </a:solidFill>
+                  </a:tcPr>
+                </a:tc>
+                <a:tc>
+                  <a:txBody>
+                    <a:bodyPr/>
+                    <a:lstStyle/>
+                    <a:p>
+                      <a:r>
+                        <a:rPr sz="1000" b="0">
+                          <a:solidFill>
+                            <a:srgbClr val="E8EAF0"/>
+                          </a:solidFill>
+                          <a:latin typeface="Calibri"/>
+                        </a:rPr>
+                        <a:t>Can users monitor state better?</a:t>
+                      </a:r>
+                    </a:p>
+                  </a:txBody>
+                  <a:tcPr>
+                    <a:solidFill>
+                      <a:srgbClr val="1A1A1F"/>
+                    </a:solidFill>
+                  </a:tcPr>
+                </a:tc>
+                <a:tc>
+                  <a:txBody>
+                    <a:bodyPr/>
+                    <a:lstStyle/>
+                    <a:p>
+                      <a:r>
+                        <a:rPr sz="1000" b="0">
+                          <a:solidFill>
+                            <a:srgbClr val="E8EAF0"/>
+                          </a:solidFill>
+                          <a:latin typeface="Calibri"/>
+                        </a:rPr>
+                        <a:t>Validates awareness training mechanics.</a:t>
+                      </a:r>
+                    </a:p>
+                  </a:txBody>
+                  <a:tcPr>
+                    <a:solidFill>
+                      <a:srgbClr val="1A1A1F"/>
+                    </a:solidFill>
+                  </a:tcPr>
+                </a:tc>
+              </a:tr>
+              <a:tr h="640080">
+                <a:tc>
+                  <a:txBody>
+                    <a:bodyPr/>
+                    <a:lstStyle/>
+                    <a:p>
+                      <a:r>
+                        <a:rPr sz="1000" b="0">
+                          <a:solidFill>
+                            <a:srgbClr val="E8EAF0"/>
+                          </a:solidFill>
+                          <a:latin typeface="Calibri"/>
+                        </a:rPr>
+                        <a:t>EQ/microbias</a:t>
+                      </a:r>
+                    </a:p>
+                  </a:txBody>
+                  <a:tcPr>
+                    <a:solidFill>
+                      <a:srgbClr val="0A0A0C"/>
+                    </a:solidFill>
+                  </a:tcPr>
+                </a:tc>
+                <a:tc>
+                  <a:txBody>
+                    <a:bodyPr/>
+                    <a:lstStyle/>
+                    <a:p>
+                      <a:r>
+                        <a:rPr sz="1000" b="0">
+                          <a:solidFill>
+                            <a:srgbClr val="E8EAF0"/>
+                          </a:solidFill>
+                          <a:latin typeface="Calibri"/>
+                        </a:rPr>
+                        <a:t>Are social reads cleaner?</a:t>
+                      </a:r>
+                    </a:p>
+                  </a:txBody>
+                  <a:tcPr>
+                    <a:solidFill>
+                      <a:srgbClr val="0A0A0C"/>
+                    </a:solidFill>
+                  </a:tcPr>
+                </a:tc>
+                <a:tc>
+                  <a:txBody>
+                    <a:bodyPr/>
+                    <a:lstStyle/>
+                    <a:p>
+                      <a:r>
+                        <a:rPr sz="1000" b="0">
+                          <a:solidFill>
+                            <a:srgbClr val="E8EAF0"/>
+                          </a:solidFill>
+                          <a:latin typeface="Calibri"/>
+                        </a:rPr>
+                        <a:t>Reduces conflict misreads and relational cost.</a:t>
+                      </a:r>
+                    </a:p>
+                  </a:txBody>
+                  <a:tcPr>
+                    <a:solidFill>
+                      <a:srgbClr val="0A0A0C"/>
+                    </a:solidFill>
+                  </a:tcPr>
+                </a:tc>
+              </a:tr>
+              <a:tr h="640080">
+                <a:tc>
+                  <a:txBody>
+                    <a:bodyPr/>
+                    <a:lstStyle/>
+                    <a:p>
+                      <a:r>
+                        <a:rPr sz="1000" b="0">
+                          <a:solidFill>
+                            <a:srgbClr val="E8EAF0"/>
+                          </a:solidFill>
+                          <a:latin typeface="Calibri"/>
+                        </a:rPr>
+                        <a:t>Impulsivity</a:t>
+                      </a:r>
+                    </a:p>
+                  </a:txBody>
+                  <a:tcPr>
+                    <a:solidFill>
+                      <a:srgbClr val="1A1A1F"/>
+                    </a:solidFill>
+                  </a:tcPr>
+                </a:tc>
+                <a:tc>
+                  <a:txBody>
+                    <a:bodyPr/>
+                    <a:lstStyle/>
+                    <a:p>
+                      <a:r>
+                        <a:rPr sz="1000" b="0">
+                          <a:solidFill>
+                            <a:srgbClr val="E8EAF0"/>
+                          </a:solidFill>
+                          <a:latin typeface="Calibri"/>
+                        </a:rPr>
+                        <a:t>Can reactions be interrupted?</a:t>
+                      </a:r>
+                    </a:p>
+                  </a:txBody>
+                  <a:tcPr>
+                    <a:solidFill>
+                      <a:srgbClr val="1A1A1F"/>
+                    </a:solidFill>
+                  </a:tcPr>
+                </a:tc>
+                <a:tc>
+                  <a:txBody>
+                    <a:bodyPr/>
+                    <a:lstStyle/>
+                    <a:p>
+                      <a:r>
+                        <a:rPr sz="1000" b="0">
+                          <a:solidFill>
+                            <a:srgbClr val="E8EAF0"/>
+                          </a:solidFill>
+                          <a:latin typeface="Calibri"/>
+                        </a:rPr>
+                        <a:t>Protects decisions in high-arousal windows.</a:t>
+                      </a:r>
+                    </a:p>
+                  </a:txBody>
+                  <a:tcPr>
+                    <a:solidFill>
+                      <a:srgbClr val="1A1A1F"/>
+                    </a:solidFill>
+                  </a:tcPr>
+                </a:tc>
+              </a:tr>
+              <a:tr h="640080">
+                <a:tc>
+                  <a:txBody>
+                    <a:bodyPr/>
+                    <a:lstStyle/>
+                    <a:p>
+                      <a:r>
+                        <a:rPr sz="1000" b="0">
+                          <a:solidFill>
+                            <a:srgbClr val="E8EAF0"/>
+                          </a:solidFill>
+                          <a:latin typeface="Calibri"/>
+                        </a:rPr>
+                        <a:t>Telemetry layer</a:t>
+                      </a:r>
+                    </a:p>
+                  </a:txBody>
+                  <a:tcPr>
+                    <a:solidFill>
+                      <a:srgbClr val="0A0A0C"/>
+                    </a:solidFill>
+                  </a:tcPr>
+                </a:tc>
+                <a:tc>
+                  <a:txBody>
+                    <a:bodyPr/>
+                    <a:lstStyle/>
+                    <a:p>
+                      <a:r>
+                        <a:rPr sz="1000" b="0">
+                          <a:solidFill>
+                            <a:srgbClr val="E8EAF0"/>
+                          </a:solidFill>
+                          <a:latin typeface="Calibri"/>
+                        </a:rPr>
+                        <a:t>Can we prove improvement?</a:t>
+                      </a:r>
+                    </a:p>
+                  </a:txBody>
+                  <a:tcPr>
+                    <a:solidFill>
+                      <a:srgbClr val="0A0A0C"/>
+                    </a:solidFill>
+                  </a:tcPr>
+                </a:tc>
+                <a:tc>
+                  <a:txBody>
+                    <a:bodyPr/>
+                    <a:lstStyle/>
+                    <a:p>
+                      <a:r>
+                        <a:rPr sz="1000" b="0">
+                          <a:solidFill>
+                            <a:srgbClr val="E8EAF0"/>
+                          </a:solidFill>
+                          <a:latin typeface="Calibri"/>
+                        </a:rPr>
+                        <a:t>Moves from claims to measurable evidence.</a:t>
+                      </a:r>
+                    </a:p>
+                  </a:txBody>
+                  <a:tcPr>
+                    <a:solidFill>
+                      <a:srgbClr val="0A0A0C"/>
+                    </a:solidFill>
+                  </a:tcPr>
+                </a:tc>
+              </a:tr>
+            </a:tbl>
           </a:graphicData>
         </a:graphic>
       </p:graphicFrame>
       <p:sp>
         <p:nvSpPr>
-          <p:cNvPr id="9" name="Rectangle 8"/>
-          <p:cNvSpPr/>
-          <p:nvPr/>
-        </p:nvSpPr>
-        <p:spPr>
-          <a:xfrm>
-            <a:off x="6355080" y="1874519"/>
-            <a:ext cx="5349240" cy="4297680"/>
-          </a:xfrm>
-          <a:prstGeom prst="rect">
-            <a:avLst/>
-          </a:prstGeom>
-          <a:solidFill>
-            <a:srgbClr val="141418"/>
-          </a:solidFill>
-          <a:ln w="11430">
-            <a:solidFill>
-              <a:srgbClr val="3D3E47"/>
-            </a:solidFill>
-          </a:ln>
-        </p:spPr>
-        <p:style>
-          <a:lnRef idx="1">
-            <a:schemeClr val="accent1"/>
-          </a:lnRef>
-          <a:fillRef idx="3">
-            <a:schemeClr val="accent1"/>
-          </a:fillRef>
-          <a:effectRef idx="2">
-            <a:schemeClr val="accent1"/>
-          </a:effectRef>
-          <a:fontRef idx="minor">
-            <a:schemeClr val="lt1"/>
-          </a:fontRef>
-        </p:style>
-        <p:txBody>
-          <a:bodyPr rtlCol="0" anchor="ctr"/>
-          <a:lstStyle/>
-          <a:p>
-            <a:pPr algn="ctr"/>
-          </a:p>
-        </p:txBody>
-      </p:sp>
-      <p:graphicFrame>
-        <p:nvGraphicFramePr>
-          <p:cNvPr id="10" name="Chart 9"/>
-          <p:cNvGraphicFramePr>
-            <a:graphicFrameLocks noGrp="1"/>
-          </p:cNvGraphicFramePr>
-          <p:nvPr/>
-        </p:nvGraphicFramePr>
-        <p:xfrm>
-          <a:off x="6583680" y="2240280"/>
-          <a:ext cx="4892040" cy="3611880"/>
-        </p:xfrm>
-        <a:graphic>
-          <a:graphicData uri="http://schemas.openxmlformats.org/drawingml/2006/chart">
-            <c:chart xmlns:c="http://schemas.openxmlformats.org/drawingml/2006/chart" r:id="rId3"/>
-          </a:graphicData>
-        </a:graphic>
-      </p:graphicFrame>
-      <p:sp>
-        <p:nvSpPr>
-          <p:cNvPr id="11" name="TextBox 10"/>
+          <p:cNvPr id="9" name="TextBox 8"/>
           <p:cNvSpPr txBox="1"/>
           <p:nvPr/>
         </p:nvSpPr>
         <p:spPr>
           <a:xfrm>
             <a:off x="685800" y="6428232"/>
-            <a:ext cx="10972800" cy="228600"/>
+            <a:ext cx="10972800" cy="219456"/>
           </a:xfrm>
           <a:prstGeom prst="rect">
             <a:avLst/>
@@ -5212,13 +5582,13 @@
           <a:lstStyle/>
           <a:p>
             <a:r>
-              <a:rPr sz="800">
+              <a:rPr sz="850">
                 <a:solidFill>
                   <a:srgbClr val="9496A1"/>
                 </a:solidFill>
                 <a:latin typeface="Consolas"/>
               </a:rPr>
-              <a:t>Source: Gallup State of the World's Emotional Health (2024)</a:t>
+              <a:t>Source: Deck framing logic tied to Stillform mechanism audit</a:t>
             </a:r>
           </a:p>
         </p:txBody>
@@ -5301,7 +5671,7 @@
         <p:spPr>
           <a:xfrm>
             <a:off x="502920" y="100584"/>
-            <a:ext cx="7315200" cy="182880"/>
+            <a:ext cx="7772400" cy="182880"/>
           </a:xfrm>
           <a:prstGeom prst="rect">
             <a:avLst/>
@@ -5315,13 +5685,13 @@
           <a:lstStyle/>
           <a:p>
             <a:r>
-              <a:rPr sz="850">
+              <a:rPr sz="900">
                 <a:solidFill>
                   <a:srgbClr val="C8922A"/>
                 </a:solidFill>
                 <a:latin typeface="Consolas"/>
               </a:rPr>
-              <a:t>STILLFORM · APPLIED SCIENCE BRIEF</a:t>
+              <a:t>STILLFORM · EXECUTIVE APPLIED SCIENCE BRIEF</a:t>
             </a:r>
           </a:p>
         </p:txBody>
@@ -5334,8 +5704,8 @@
         </p:nvSpPr>
         <p:spPr>
           <a:xfrm>
-            <a:off x="10149840" y="100584"/>
-            <a:ext cx="1554480" cy="182880"/>
+            <a:off x="10241280" y="100584"/>
+            <a:ext cx="1463040" cy="182880"/>
           </a:xfrm>
           <a:prstGeom prst="rect">
             <a:avLst/>
@@ -5350,7 +5720,7 @@
           <a:p>
             <a:pPr algn="r"/>
             <a:r>
-              <a:rPr sz="850">
+              <a:rPr sz="900">
                 <a:solidFill>
                   <a:srgbClr val="9496A1"/>
                 </a:solidFill>
@@ -5370,7 +5740,7 @@
         <p:spPr>
           <a:xfrm>
             <a:off x="640080" y="640080"/>
-            <a:ext cx="10972800" cy="1005840"/>
+            <a:ext cx="10972800" cy="960120"/>
           </a:xfrm>
           <a:prstGeom prst="rect">
             <a:avLst/>
@@ -5384,13 +5754,13 @@
           <a:lstStyle/>
           <a:p>
             <a:r>
-              <a:rPr sz="3600" b="1">
+              <a:rPr sz="3800" b="1">
                 <a:solidFill>
                   <a:srgbClr val="E8EAF0"/>
                 </a:solidFill>
                 <a:latin typeface="Calibri"/>
               </a:rPr>
-              <a:t>How Stillform Works</a:t>
+              <a:t>Global Context</a:t>
             </a:r>
           </a:p>
         </p:txBody>
@@ -5403,8 +5773,8 @@
         </p:nvSpPr>
         <p:spPr>
           <a:xfrm>
-            <a:off x="658368" y="1417320"/>
-            <a:ext cx="10972800" cy="365760"/>
+            <a:off x="676656" y="1417320"/>
+            <a:ext cx="10881360" cy="411480"/>
           </a:xfrm>
           <a:prstGeom prst="rect">
             <a:avLst/>
@@ -5418,595 +5788,153 @@
           <a:lstStyle/>
           <a:p>
             <a:r>
-              <a:rPr sz="1400">
+              <a:rPr sz="1500">
                 <a:solidFill>
                   <a:srgbClr val="9496A1"/>
                 </a:solidFill>
                 <a:latin typeface="Calibri"/>
               </a:rPr>
-              <a:t>Applied science -&gt; mechanism -&gt; signal</a:t>
-            </a:r>
+              <a:t>Pressure remains high; composure capacity is uneven</a:t>
+            </a:r>
+          </a:p>
+        </p:txBody>
+      </p:sp>
+      <p:sp>
+        <p:nvSpPr>
+          <p:cNvPr id="7" name="Rectangle 6"/>
+          <p:cNvSpPr/>
+          <p:nvPr/>
+        </p:nvSpPr>
+        <p:spPr>
+          <a:xfrm>
+            <a:off x="685800" y="1874519"/>
+            <a:ext cx="5486400" cy="4389120"/>
+          </a:xfrm>
+          <a:prstGeom prst="rect">
+            <a:avLst/>
+          </a:prstGeom>
+          <a:solidFill>
+            <a:srgbClr val="141418"/>
+          </a:solidFill>
+          <a:ln w="12700">
+            <a:solidFill>
+              <a:srgbClr val="3A3A42"/>
+            </a:solidFill>
+          </a:ln>
+        </p:spPr>
+        <p:style>
+          <a:lnRef idx="1">
+            <a:schemeClr val="accent1"/>
+          </a:lnRef>
+          <a:fillRef idx="3">
+            <a:schemeClr val="accent1"/>
+          </a:fillRef>
+          <a:effectRef idx="2">
+            <a:schemeClr val="accent1"/>
+          </a:effectRef>
+          <a:fontRef idx="minor">
+            <a:schemeClr val="lt1"/>
+          </a:fontRef>
+        </p:style>
+        <p:txBody>
+          <a:bodyPr rtlCol="0" anchor="ctr"/>
+          <a:lstStyle/>
+          <a:p>
+            <a:pPr algn="ctr"/>
           </a:p>
         </p:txBody>
       </p:sp>
       <p:graphicFrame>
         <p:nvGraphicFramePr>
-          <p:cNvPr id="7" name="Table 6"/>
+          <p:cNvPr id="8" name="Chart 7"/>
           <p:cNvGraphicFramePr>
             <a:graphicFrameLocks noGrp="1"/>
           </p:cNvGraphicFramePr>
           <p:nvPr/>
         </p:nvGraphicFramePr>
         <p:xfrm>
-          <a:off x="594360" y="1828800"/>
-          <a:ext cx="11064240" cy="4526280"/>
+          <a:off x="914400" y="2240280"/>
+          <a:ext cx="5074920" cy="3611880"/>
         </p:xfrm>
         <a:graphic>
-          <a:graphicData uri="http://schemas.openxmlformats.org/drawingml/2006/table">
-            <a:tbl>
-              <a:tblPr firstRow="1" bandRow="1">
-                <a:tableStyleId>{5C22544A-7EE6-4342-B048-85BDC9FD1C3A}</a:tableStyleId>
-              </a:tblPr>
-              <a:tblGrid>
-                <a:gridCol w="1920240"/>
-                <a:gridCol w="2926080"/>
-                <a:gridCol w="3291840"/>
-                <a:gridCol w="2926080"/>
-              </a:tblGrid>
-              <a:tr h="754380">
-                <a:tc>
-                  <a:txBody>
-                    <a:bodyPr/>
-                    <a:lstStyle/>
-                    <a:p>
-                      <a:r>
-                        <a:rPr sz="1000" b="1">
-                          <a:solidFill>
-                            <a:srgbClr val="C8922A"/>
-                          </a:solidFill>
-                          <a:latin typeface="Calibri"/>
-                        </a:rPr>
-                        <a:t>Domain</a:t>
-                      </a:r>
-                    </a:p>
-                  </a:txBody>
-                  <a:tcPr>
-                    <a:solidFill>
-                      <a:srgbClr val="141418"/>
-                    </a:solidFill>
-                  </a:tcPr>
-                </a:tc>
-                <a:tc>
-                  <a:txBody>
-                    <a:bodyPr/>
-                    <a:lstStyle/>
-                    <a:p>
-                      <a:r>
-                        <a:rPr sz="1000" b="1">
-                          <a:solidFill>
-                            <a:srgbClr val="C8922A"/>
-                          </a:solidFill>
-                          <a:latin typeface="Calibri"/>
-                        </a:rPr>
-                        <a:t>Issue</a:t>
-                      </a:r>
-                    </a:p>
-                  </a:txBody>
-                  <a:tcPr>
-                    <a:solidFill>
-                      <a:srgbClr val="141418"/>
-                    </a:solidFill>
-                  </a:tcPr>
-                </a:tc>
-                <a:tc>
-                  <a:txBody>
-                    <a:bodyPr/>
-                    <a:lstStyle/>
-                    <a:p>
-                      <a:r>
-                        <a:rPr sz="1000" b="1">
-                          <a:solidFill>
-                            <a:srgbClr val="C8922A"/>
-                          </a:solidFill>
-                          <a:latin typeface="Calibri"/>
-                        </a:rPr>
-                        <a:t>Stillform mechanism</a:t>
-                      </a:r>
-                    </a:p>
-                  </a:txBody>
-                  <a:tcPr>
-                    <a:solidFill>
-                      <a:srgbClr val="141418"/>
-                    </a:solidFill>
-                  </a:tcPr>
-                </a:tc>
-                <a:tc>
-                  <a:txBody>
-                    <a:bodyPr/>
-                    <a:lstStyle/>
-                    <a:p>
-                      <a:r>
-                        <a:rPr sz="1000" b="1">
-                          <a:solidFill>
-                            <a:srgbClr val="C8922A"/>
-                          </a:solidFill>
-                          <a:latin typeface="Calibri"/>
-                        </a:rPr>
-                        <a:t>Measured signal</a:t>
-                      </a:r>
-                    </a:p>
-                  </a:txBody>
-                  <a:tcPr>
-                    <a:solidFill>
-                      <a:srgbClr val="141418"/>
-                    </a:solidFill>
-                  </a:tcPr>
-                </a:tc>
-              </a:tr>
-              <a:tr h="754380">
-                <a:tc>
-                  <a:txBody>
-                    <a:bodyPr/>
-                    <a:lstStyle/>
-                    <a:p>
-                      <a:r>
-                        <a:rPr sz="950" b="0">
-                          <a:solidFill>
-                            <a:srgbClr val="E8EAF0"/>
-                          </a:solidFill>
-                          <a:latin typeface="Calibri"/>
-                        </a:rPr>
-                        <a:t>Metacognition</a:t>
-                      </a:r>
-                    </a:p>
-                  </a:txBody>
-                  <a:tcPr>
-                    <a:solidFill>
-                      <a:srgbClr val="0A0A0C"/>
-                    </a:solidFill>
-                  </a:tcPr>
-                </a:tc>
-                <a:tc>
-                  <a:txBody>
-                    <a:bodyPr/>
-                    <a:lstStyle/>
-                    <a:p>
-                      <a:r>
-                        <a:rPr sz="950" b="0">
-                          <a:solidFill>
-                            <a:srgbClr val="E8EAF0"/>
-                          </a:solidFill>
-                          <a:latin typeface="Calibri"/>
-                        </a:rPr>
-                        <a:t>High stress narrows self-monitoring</a:t>
-                      </a:r>
-                    </a:p>
-                  </a:txBody>
-                  <a:tcPr>
-                    <a:solidFill>
-                      <a:srgbClr val="0A0A0C"/>
-                    </a:solidFill>
-                  </a:tcPr>
-                </a:tc>
-                <a:tc>
-                  <a:txBody>
-                    <a:bodyPr/>
-                    <a:lstStyle/>
-                    <a:p>
-                      <a:r>
-                        <a:rPr sz="950" b="0">
-                          <a:solidFill>
-                            <a:srgbClr val="E8EAF0"/>
-                          </a:solidFill>
-                          <a:latin typeface="Calibri"/>
-                        </a:rPr>
-                        <a:t>Affect labeling + pattern reflection</a:t>
-                      </a:r>
-                    </a:p>
-                  </a:txBody>
-                  <a:tcPr>
-                    <a:solidFill>
-                      <a:srgbClr val="0A0A0C"/>
-                    </a:solidFill>
-                  </a:tcPr>
-                </a:tc>
-                <a:tc>
-                  <a:txBody>
-                    <a:bodyPr/>
-                    <a:lstStyle/>
-                    <a:p>
-                      <a:r>
-                        <a:rPr sz="950" b="0">
-                          <a:solidFill>
-                            <a:srgbClr val="E8EAF0"/>
-                          </a:solidFill>
-                          <a:latin typeface="Calibri"/>
-                        </a:rPr>
-                        <a:t>Pre/post composure shift</a:t>
-                      </a:r>
-                    </a:p>
-                  </a:txBody>
-                  <a:tcPr>
-                    <a:solidFill>
-                      <a:srgbClr val="0A0A0C"/>
-                    </a:solidFill>
-                  </a:tcPr>
-                </a:tc>
-              </a:tr>
-              <a:tr h="754380">
-                <a:tc>
-                  <a:txBody>
-                    <a:bodyPr/>
-                    <a:lstStyle/>
-                    <a:p>
-                      <a:r>
-                        <a:rPr sz="950" b="0">
-                          <a:solidFill>
-                            <a:srgbClr val="E8EAF0"/>
-                          </a:solidFill>
-                          <a:latin typeface="Calibri"/>
-                        </a:rPr>
-                        <a:t>EQ</a:t>
-                      </a:r>
-                    </a:p>
-                  </a:txBody>
-                  <a:tcPr>
-                    <a:solidFill>
-                      <a:srgbClr val="1A1A1F"/>
-                    </a:solidFill>
-                  </a:tcPr>
-                </a:tc>
-                <a:tc>
-                  <a:txBody>
-                    <a:bodyPr/>
-                    <a:lstStyle/>
-                    <a:p>
-                      <a:r>
-                        <a:rPr sz="950" b="0">
-                          <a:solidFill>
-                            <a:srgbClr val="E8EAF0"/>
-                          </a:solidFill>
-                          <a:latin typeface="Calibri"/>
-                        </a:rPr>
-                        <a:t>State noise distorts social reads</a:t>
-                      </a:r>
-                    </a:p>
-                  </a:txBody>
-                  <a:tcPr>
-                    <a:solidFill>
-                      <a:srgbClr val="1A1A1F"/>
-                    </a:solidFill>
-                  </a:tcPr>
-                </a:tc>
-                <a:tc>
-                  <a:txBody>
-                    <a:bodyPr/>
-                    <a:lstStyle/>
-                    <a:p>
-                      <a:r>
-                        <a:rPr sz="950" b="0">
-                          <a:solidFill>
-                            <a:srgbClr val="E8EAF0"/>
-                          </a:solidFill>
-                          <a:latin typeface="Calibri"/>
-                        </a:rPr>
-                        <a:t>Bio-filter + microbias prompting</a:t>
-                      </a:r>
-                    </a:p>
-                  </a:txBody>
-                  <a:tcPr>
-                    <a:solidFill>
-                      <a:srgbClr val="1A1A1F"/>
-                    </a:solidFill>
-                  </a:tcPr>
-                </a:tc>
-                <a:tc>
-                  <a:txBody>
-                    <a:bodyPr/>
-                    <a:lstStyle/>
-                    <a:p>
-                      <a:r>
-                        <a:rPr sz="950" b="0">
-                          <a:solidFill>
-                            <a:srgbClr val="E8EAF0"/>
-                          </a:solidFill>
-                          <a:latin typeface="Calibri"/>
-                        </a:rPr>
-                        <a:t>Conflict-loop reduction</a:t>
-                      </a:r>
-                    </a:p>
-                  </a:txBody>
-                  <a:tcPr>
-                    <a:solidFill>
-                      <a:srgbClr val="1A1A1F"/>
-                    </a:solidFill>
-                  </a:tcPr>
-                </a:tc>
-              </a:tr>
-              <a:tr h="754380">
-                <a:tc>
-                  <a:txBody>
-                    <a:bodyPr/>
-                    <a:lstStyle/>
-                    <a:p>
-                      <a:r>
-                        <a:rPr sz="950" b="0">
-                          <a:solidFill>
-                            <a:srgbClr val="E8EAF0"/>
-                          </a:solidFill>
-                          <a:latin typeface="Calibri"/>
-                        </a:rPr>
-                        <a:t>Composure</a:t>
-                      </a:r>
-                    </a:p>
-                  </a:txBody>
-                  <a:tcPr>
-                    <a:solidFill>
-                      <a:srgbClr val="0A0A0C"/>
-                    </a:solidFill>
-                  </a:tcPr>
-                </a:tc>
-                <a:tc>
-                  <a:txBody>
-                    <a:bodyPr/>
-                    <a:lstStyle/>
-                    <a:p>
-                      <a:r>
-                        <a:rPr sz="950" b="0">
-                          <a:solidFill>
-                            <a:srgbClr val="E8EAF0"/>
-                          </a:solidFill>
-                          <a:latin typeface="Calibri"/>
-                        </a:rPr>
-                        <a:t>Inconsistent daily regulation</a:t>
-                      </a:r>
-                    </a:p>
-                  </a:txBody>
-                  <a:tcPr>
-                    <a:solidFill>
-                      <a:srgbClr val="0A0A0C"/>
-                    </a:solidFill>
-                  </a:tcPr>
-                </a:tc>
-                <a:tc>
-                  <a:txBody>
-                    <a:bodyPr/>
-                    <a:lstStyle/>
-                    <a:p>
-                      <a:r>
-                        <a:rPr sz="950" b="0">
-                          <a:solidFill>
-                            <a:srgbClr val="E8EAF0"/>
-                          </a:solidFill>
-                          <a:latin typeface="Calibri"/>
-                        </a:rPr>
-                        <a:t>Morning baseline + EOD close</a:t>
-                      </a:r>
-                    </a:p>
-                  </a:txBody>
-                  <a:tcPr>
-                    <a:solidFill>
-                      <a:srgbClr val="0A0A0C"/>
-                    </a:solidFill>
-                  </a:tcPr>
-                </a:tc>
-                <a:tc>
-                  <a:txBody>
-                    <a:bodyPr/>
-                    <a:lstStyle/>
-                    <a:p>
-                      <a:r>
-                        <a:rPr sz="950" b="0">
-                          <a:solidFill>
-                            <a:srgbClr val="E8EAF0"/>
-                          </a:solidFill>
-                          <a:latin typeface="Calibri"/>
-                        </a:rPr>
-                        <a:t>14d loop completion</a:t>
-                      </a:r>
-                    </a:p>
-                  </a:txBody>
-                  <a:tcPr>
-                    <a:solidFill>
-                      <a:srgbClr val="0A0A0C"/>
-                    </a:solidFill>
-                  </a:tcPr>
-                </a:tc>
-              </a:tr>
-              <a:tr h="754380">
-                <a:tc>
-                  <a:txBody>
-                    <a:bodyPr/>
-                    <a:lstStyle/>
-                    <a:p>
-                      <a:r>
-                        <a:rPr sz="950" b="0">
-                          <a:solidFill>
-                            <a:srgbClr val="E8EAF0"/>
-                          </a:solidFill>
-                          <a:latin typeface="Calibri"/>
-                        </a:rPr>
-                        <a:t>Impulsivity</a:t>
-                      </a:r>
-                    </a:p>
-                  </a:txBody>
-                  <a:tcPr>
-                    <a:solidFill>
-                      <a:srgbClr val="1A1A1F"/>
-                    </a:solidFill>
-                  </a:tcPr>
-                </a:tc>
-                <a:tc>
-                  <a:txBody>
-                    <a:bodyPr/>
-                    <a:lstStyle/>
-                    <a:p>
-                      <a:r>
-                        <a:rPr sz="950" b="0">
-                          <a:solidFill>
-                            <a:srgbClr val="E8EAF0"/>
-                          </a:solidFill>
-                          <a:latin typeface="Calibri"/>
-                        </a:rPr>
-                        <a:t>Fast state -&gt; fast reactions</a:t>
-                      </a:r>
-                    </a:p>
-                  </a:txBody>
-                  <a:tcPr>
-                    <a:solidFill>
-                      <a:srgbClr val="1A1A1F"/>
-                    </a:solidFill>
-                  </a:tcPr>
-                </a:tc>
-                <a:tc>
-                  <a:txBody>
-                    <a:bodyPr/>
-                    <a:lstStyle/>
-                    <a:p>
-                      <a:r>
-                        <a:rPr sz="950" b="0">
-                          <a:solidFill>
-                            <a:srgbClr val="E8EAF0"/>
-                          </a:solidFill>
-                          <a:latin typeface="Calibri"/>
-                        </a:rPr>
-                        <a:t>Somatic interrupt + default pathway</a:t>
-                      </a:r>
-                    </a:p>
-                  </a:txBody>
-                  <a:tcPr>
-                    <a:solidFill>
-                      <a:srgbClr val="1A1A1F"/>
-                    </a:solidFill>
-                  </a:tcPr>
-                </a:tc>
-                <a:tc>
-                  <a:txBody>
-                    <a:bodyPr/>
-                    <a:lstStyle/>
-                    <a:p>
-                      <a:r>
-                        <a:rPr sz="950" b="0">
-                          <a:solidFill>
-                            <a:srgbClr val="E8EAF0"/>
-                          </a:solidFill>
-                          <a:latin typeface="Calibri"/>
-                        </a:rPr>
-                        <a:t>Time-to-stabilization</a:t>
-                      </a:r>
-                    </a:p>
-                  </a:txBody>
-                  <a:tcPr>
-                    <a:solidFill>
-                      <a:srgbClr val="1A1A1F"/>
-                    </a:solidFill>
-                  </a:tcPr>
-                </a:tc>
-              </a:tr>
-              <a:tr h="754380">
-                <a:tc>
-                  <a:txBody>
-                    <a:bodyPr/>
-                    <a:lstStyle/>
-                    <a:p>
-                      <a:r>
-                        <a:rPr sz="950" b="0">
-                          <a:solidFill>
-                            <a:srgbClr val="E8EAF0"/>
-                          </a:solidFill>
-                          <a:latin typeface="Calibri"/>
-                        </a:rPr>
-                        <a:t>Microbias</a:t>
-                      </a:r>
-                    </a:p>
-                  </a:txBody>
-                  <a:tcPr>
-                    <a:solidFill>
-                      <a:srgbClr val="0A0A0C"/>
-                    </a:solidFill>
-                  </a:tcPr>
-                </a:tc>
-                <a:tc>
-                  <a:txBody>
-                    <a:bodyPr/>
-                    <a:lstStyle/>
-                    <a:p>
-                      <a:r>
-                        <a:rPr sz="950" b="0">
-                          <a:solidFill>
-                            <a:srgbClr val="E8EAF0"/>
-                          </a:solidFill>
-                          <a:latin typeface="Calibri"/>
-                        </a:rPr>
-                        <a:t>20-30% overread of negative intensity</a:t>
-                      </a:r>
-                    </a:p>
-                  </a:txBody>
-                  <a:tcPr>
-                    <a:solidFill>
-                      <a:srgbClr val="0A0A0C"/>
-                    </a:solidFill>
-                  </a:tcPr>
-                </a:tc>
-                <a:tc>
-                  <a:txBody>
-                    <a:bodyPr/>
-                    <a:lstStyle/>
-                    <a:p>
-                      <a:r>
-                        <a:rPr sz="950" b="0">
-                          <a:solidFill>
-                            <a:srgbClr val="E8EAF0"/>
-                          </a:solidFill>
-                          <a:latin typeface="Calibri"/>
-                        </a:rPr>
-                        <a:t>Projection/attribution checks</a:t>
-                      </a:r>
-                    </a:p>
-                  </a:txBody>
-                  <a:tcPr>
-                    <a:solidFill>
-                      <a:srgbClr val="0A0A0C"/>
-                    </a:solidFill>
-                  </a:tcPr>
-                </a:tc>
-                <a:tc>
-                  <a:txBody>
-                    <a:bodyPr/>
-                    <a:lstStyle/>
-                    <a:p>
-                      <a:r>
-                        <a:rPr sz="950" b="0">
-                          <a:solidFill>
-                            <a:srgbClr val="E8EAF0"/>
-                          </a:solidFill>
-                          <a:latin typeface="Calibri"/>
-                        </a:rPr>
-                        <a:t>Bias-tag recurrence trend</a:t>
-                      </a:r>
-                    </a:p>
-                  </a:txBody>
-                  <a:tcPr>
-                    <a:solidFill>
-                      <a:srgbClr val="0A0A0C"/>
-                    </a:solidFill>
-                  </a:tcPr>
-                </a:tc>
-              </a:tr>
-            </a:tbl>
+          <a:graphicData uri="http://schemas.openxmlformats.org/drawingml/2006/chart">
+            <c:chart xmlns:c="http://schemas.openxmlformats.org/drawingml/2006/chart" r:id="rId2"/>
           </a:graphicData>
         </a:graphic>
       </p:graphicFrame>
       <p:sp>
         <p:nvSpPr>
-          <p:cNvPr id="8" name="TextBox 7"/>
+          <p:cNvPr id="9" name="Rectangle 8"/>
+          <p:cNvSpPr/>
+          <p:nvPr/>
+        </p:nvSpPr>
+        <p:spPr>
+          <a:xfrm>
+            <a:off x="6355080" y="1874519"/>
+            <a:ext cx="5349240" cy="4389120"/>
+          </a:xfrm>
+          <a:prstGeom prst="rect">
+            <a:avLst/>
+          </a:prstGeom>
+          <a:solidFill>
+            <a:srgbClr val="1A1A1F"/>
+          </a:solidFill>
+          <a:ln w="12700">
+            <a:solidFill>
+              <a:srgbClr val="3A3A42"/>
+            </a:solidFill>
+          </a:ln>
+        </p:spPr>
+        <p:style>
+          <a:lnRef idx="1">
+            <a:schemeClr val="accent1"/>
+          </a:lnRef>
+          <a:fillRef idx="3">
+            <a:schemeClr val="accent1"/>
+          </a:fillRef>
+          <a:effectRef idx="2">
+            <a:schemeClr val="accent1"/>
+          </a:effectRef>
+          <a:fontRef idx="minor">
+            <a:schemeClr val="lt1"/>
+          </a:fontRef>
+        </p:style>
+        <p:txBody>
+          <a:bodyPr rtlCol="0" anchor="ctr"/>
+          <a:lstStyle/>
+          <a:p>
+            <a:pPr algn="ctr"/>
+          </a:p>
+        </p:txBody>
+      </p:sp>
+      <p:graphicFrame>
+        <p:nvGraphicFramePr>
+          <p:cNvPr id="10" name="Chart 9"/>
+          <p:cNvGraphicFramePr>
+            <a:graphicFrameLocks noGrp="1"/>
+          </p:cNvGraphicFramePr>
+          <p:nvPr/>
+        </p:nvGraphicFramePr>
+        <p:xfrm>
+          <a:off x="6583680" y="2240280"/>
+          <a:ext cx="4937760" cy="3611880"/>
+        </p:xfrm>
+        <a:graphic>
+          <a:graphicData uri="http://schemas.openxmlformats.org/drawingml/2006/chart">
+            <c:chart xmlns:c="http://schemas.openxmlformats.org/drawingml/2006/chart" r:id="rId3"/>
+          </a:graphicData>
+        </a:graphic>
+      </p:graphicFrame>
+      <p:sp>
+        <p:nvSpPr>
+          <p:cNvPr id="11" name="TextBox 10"/>
           <p:cNvSpPr txBox="1"/>
           <p:nvPr/>
         </p:nvSpPr>
         <p:spPr>
           <a:xfrm>
             <a:off x="685800" y="6428232"/>
-            <a:ext cx="10972800" cy="228600"/>
+            <a:ext cx="10972800" cy="219456"/>
           </a:xfrm>
           <a:prstGeom prst="rect">
             <a:avLst/>
@@ -6020,13 +5948,13 @@
           <a:lstStyle/>
           <a:p>
             <a:r>
-              <a:rPr sz="800">
+              <a:rPr sz="850">
                 <a:solidFill>
                   <a:srgbClr val="9496A1"/>
                 </a:solidFill>
                 <a:latin typeface="Consolas"/>
               </a:rPr>
-              <a:t>Source: Stillform science sheet + App.jsx loop/nudge/rating instrumentation</a:t>
+              <a:t>Source: Gallup State of the World's Emotional Health (2024)</a:t>
             </a:r>
           </a:p>
         </p:txBody>
@@ -6109,7 +6037,7 @@
         <p:spPr>
           <a:xfrm>
             <a:off x="502920" y="100584"/>
-            <a:ext cx="7315200" cy="182880"/>
+            <a:ext cx="7772400" cy="182880"/>
           </a:xfrm>
           <a:prstGeom prst="rect">
             <a:avLst/>
@@ -6123,13 +6051,13 @@
           <a:lstStyle/>
           <a:p>
             <a:r>
-              <a:rPr sz="850">
+              <a:rPr sz="900">
                 <a:solidFill>
                   <a:srgbClr val="C8922A"/>
                 </a:solidFill>
                 <a:latin typeface="Consolas"/>
               </a:rPr>
-              <a:t>STILLFORM · APPLIED SCIENCE BRIEF</a:t>
+              <a:t>STILLFORM · EXECUTIVE APPLIED SCIENCE BRIEF</a:t>
             </a:r>
           </a:p>
         </p:txBody>
@@ -6142,8 +6070,8 @@
         </p:nvSpPr>
         <p:spPr>
           <a:xfrm>
-            <a:off x="10149840" y="100584"/>
-            <a:ext cx="1554480" cy="182880"/>
+            <a:off x="10241280" y="100584"/>
+            <a:ext cx="1463040" cy="182880"/>
           </a:xfrm>
           <a:prstGeom prst="rect">
             <a:avLst/>
@@ -6158,7 +6086,7 @@
           <a:p>
             <a:pPr algn="r"/>
             <a:r>
-              <a:rPr sz="850">
+              <a:rPr sz="900">
                 <a:solidFill>
                   <a:srgbClr val="9496A1"/>
                 </a:solidFill>
@@ -6178,7 +6106,7 @@
         <p:spPr>
           <a:xfrm>
             <a:off x="640080" y="640080"/>
-            <a:ext cx="10972800" cy="1005840"/>
+            <a:ext cx="10972800" cy="960120"/>
           </a:xfrm>
           <a:prstGeom prst="rect">
             <a:avLst/>
@@ -6192,7 +6120,7 @@
           <a:lstStyle/>
           <a:p>
             <a:r>
-              <a:rPr sz="3600" b="1">
+              <a:rPr sz="3800" b="1">
                 <a:solidFill>
                   <a:srgbClr val="E8EAF0"/>
                 </a:solidFill>
@@ -6211,8 +6139,8 @@
         </p:nvSpPr>
         <p:spPr>
           <a:xfrm>
-            <a:off x="658368" y="1417320"/>
-            <a:ext cx="10972800" cy="365760"/>
+            <a:off x="676656" y="1417320"/>
+            <a:ext cx="10881360" cy="411480"/>
           </a:xfrm>
           <a:prstGeom prst="rect">
             <a:avLst/>
@@ -6226,7 +6154,7 @@
           <a:lstStyle/>
           <a:p>
             <a:r>
-              <a:rPr sz="1400">
+              <a:rPr sz="1500">
                 <a:solidFill>
                   <a:srgbClr val="9496A1"/>
                 </a:solidFill>
@@ -6246,7 +6174,7 @@
         <p:spPr>
           <a:xfrm>
             <a:off x="685800" y="1874519"/>
-            <a:ext cx="7223760" cy="4297680"/>
+            <a:ext cx="7406640" cy="4389120"/>
           </a:xfrm>
           <a:prstGeom prst="rect">
             <a:avLst/>
@@ -6254,9 +6182,9 @@
           <a:solidFill>
             <a:srgbClr val="141418"/>
           </a:solidFill>
-          <a:ln w="11430">
+          <a:ln w="12700">
             <a:solidFill>
-              <a:srgbClr val="3D3E47"/>
+              <a:srgbClr val="3A3A42"/>
             </a:solidFill>
           </a:ln>
         </p:spPr>
@@ -6292,7 +6220,7 @@
         </p:nvGraphicFramePr>
         <p:xfrm>
           <a:off x="960120" y="2240280"/>
-          <a:ext cx="6720840" cy="3611880"/>
+          <a:ext cx="6903720" cy="3611880"/>
         </p:xfrm>
         <a:graphic>
           <a:graphicData uri="http://schemas.openxmlformats.org/drawingml/2006/chart">
@@ -6308,8 +6236,8 @@
         </p:nvSpPr>
         <p:spPr>
           <a:xfrm>
-            <a:off x="8183879" y="1874519"/>
-            <a:ext cx="3520440" cy="4297680"/>
+            <a:off x="8321040" y="1874519"/>
+            <a:ext cx="3383280" cy="4389120"/>
           </a:xfrm>
           <a:prstGeom prst="rect">
             <a:avLst/>
@@ -6317,9 +6245,9 @@
           <a:solidFill>
             <a:srgbClr val="1A1A1F"/>
           </a:solidFill>
-          <a:ln w="11430">
+          <a:ln w="12700">
             <a:solidFill>
-              <a:srgbClr val="3D3E47"/>
+              <a:srgbClr val="3A3A42"/>
             </a:solidFill>
           </a:ln>
         </p:spPr>
@@ -6353,8 +6281,8 @@
         </p:nvSpPr>
         <p:spPr>
           <a:xfrm>
-            <a:off x="8348471" y="2039111"/>
-            <a:ext cx="3200400" cy="3977640"/>
+            <a:off x="8595360" y="2240280"/>
+            <a:ext cx="2926080" cy="3566160"/>
           </a:xfrm>
           <a:prstGeom prst="rect">
             <a:avLst/>
@@ -6362,27 +6290,16 @@
           <a:noFill/>
         </p:spPr>
         <p:txBody>
-          <a:bodyPr wrap="none">
+          <a:bodyPr wrap="square">
             <a:spAutoFit/>
           </a:bodyPr>
           <a:lstStyle/>
           <a:p>
-            <a:r>
-              <a:rPr sz="1500" b="1">
-                <a:solidFill>
-                  <a:srgbClr val="C8922A"/>
-                </a:solidFill>
-                <a:latin typeface="Calibri"/>
-              </a:rPr>
-              <a:t>How this works in-app</a:t>
-            </a:r>
-          </a:p>
-          <a:p>
             <a:pPr>
               <a:spcAft>
-                <a:spcPts val="600"/>
+                <a:spcPts val="900"/>
               </a:spcAft>
-              <a:defRPr sz="1200">
+              <a:defRPr sz="1600" b="1">
                 <a:solidFill>
                   <a:srgbClr val="E8EAF0"/>
                 </a:solidFill>
@@ -6390,15 +6307,15 @@
               </a:defRPr>
             </a:pPr>
             <a:r>
-              <a:t>Pulse emotion chips perform affect labeling.</a:t>
+              <a:t>How Stillform applies this:</a:t>
             </a:r>
           </a:p>
           <a:p>
             <a:pPr>
               <a:spcAft>
-                <a:spcPts val="600"/>
+                <a:spcPts val="700"/>
               </a:spcAft>
-              <a:defRPr sz="1200">
+              <a:defRPr sz="1300" b="0">
                 <a:solidFill>
                   <a:srgbClr val="E8EAF0"/>
                 </a:solidFill>
@@ -6406,15 +6323,15 @@
               </a:defRPr>
             </a:pPr>
             <a:r>
-              <a:t>Reframe reflects patterns back as operational language.</a:t>
+              <a:t>Pulse emotion labeling trains state naming (affect labeling).</a:t>
             </a:r>
           </a:p>
           <a:p>
             <a:pPr>
               <a:spcAft>
-                <a:spcPts val="600"/>
+                <a:spcPts val="700"/>
               </a:spcAft>
-              <a:defRPr sz="1200">
+              <a:defRPr sz="1300" b="0">
                 <a:solidFill>
                   <a:srgbClr val="E8EAF0"/>
                 </a:solidFill>
@@ -6422,7 +6339,23 @@
               </a:defRPr>
             </a:pPr>
             <a:r>
-              <a:t>Output target: clearer next-action selection under load.</a:t>
+              <a:t>Reframe then converts state awareness into action selection.</a:t>
+            </a:r>
+          </a:p>
+          <a:p>
+            <a:pPr>
+              <a:spcAft>
+                <a:spcPts val="700"/>
+              </a:spcAft>
+              <a:defRPr sz="1300" b="0">
+                <a:solidFill>
+                  <a:srgbClr val="E8EAF0"/>
+                </a:solidFill>
+                <a:latin typeface="Calibri"/>
+              </a:defRPr>
+            </a:pPr>
+            <a:r>
+              <a:t>Measured by pre/post composure delta trends over sessions.</a:t>
             </a:r>
           </a:p>
         </p:txBody>
@@ -6436,7 +6369,7 @@
         <p:spPr>
           <a:xfrm>
             <a:off x="685800" y="6428232"/>
-            <a:ext cx="10972800" cy="228600"/>
+            <a:ext cx="10972800" cy="219456"/>
           </a:xfrm>
           <a:prstGeom prst="rect">
             <a:avLst/>
@@ -6450,7 +6383,7 @@
           <a:lstStyle/>
           <a:p>
             <a:r>
-              <a:rPr sz="800">
+              <a:rPr sz="850">
                 <a:solidFill>
                   <a:srgbClr val="9496A1"/>
                 </a:solidFill>
@@ -6539,7 +6472,7 @@
         <p:spPr>
           <a:xfrm>
             <a:off x="502920" y="100584"/>
-            <a:ext cx="7315200" cy="182880"/>
+            <a:ext cx="7772400" cy="182880"/>
           </a:xfrm>
           <a:prstGeom prst="rect">
             <a:avLst/>
@@ -6553,13 +6486,13 @@
           <a:lstStyle/>
           <a:p>
             <a:r>
-              <a:rPr sz="850">
+              <a:rPr sz="900">
                 <a:solidFill>
                   <a:srgbClr val="C8922A"/>
                 </a:solidFill>
                 <a:latin typeface="Consolas"/>
               </a:rPr>
-              <a:t>STILLFORM · APPLIED SCIENCE BRIEF</a:t>
+              <a:t>STILLFORM · EXECUTIVE APPLIED SCIENCE BRIEF</a:t>
             </a:r>
           </a:p>
         </p:txBody>
@@ -6572,8 +6505,8 @@
         </p:nvSpPr>
         <p:spPr>
           <a:xfrm>
-            <a:off x="10149840" y="100584"/>
-            <a:ext cx="1554480" cy="182880"/>
+            <a:off x="10241280" y="100584"/>
+            <a:ext cx="1463040" cy="182880"/>
           </a:xfrm>
           <a:prstGeom prst="rect">
             <a:avLst/>
@@ -6588,7 +6521,7 @@
           <a:p>
             <a:pPr algn="r"/>
             <a:r>
-              <a:rPr sz="850">
+              <a:rPr sz="900">
                 <a:solidFill>
                   <a:srgbClr val="9496A1"/>
                 </a:solidFill>
@@ -6608,7 +6541,7 @@
         <p:spPr>
           <a:xfrm>
             <a:off x="640080" y="640080"/>
-            <a:ext cx="10972800" cy="1005840"/>
+            <a:ext cx="10972800" cy="960120"/>
           </a:xfrm>
           <a:prstGeom prst="rect">
             <a:avLst/>
@@ -6622,7 +6555,7 @@
           <a:lstStyle/>
           <a:p>
             <a:r>
-              <a:rPr sz="3600" b="1">
+              <a:rPr sz="3800" b="1">
                 <a:solidFill>
                   <a:srgbClr val="E8EAF0"/>
                 </a:solidFill>
@@ -6641,8 +6574,8 @@
         </p:nvSpPr>
         <p:spPr>
           <a:xfrm>
-            <a:off x="658368" y="1417320"/>
-            <a:ext cx="10972800" cy="365760"/>
+            <a:off x="676656" y="1417320"/>
+            <a:ext cx="10881360" cy="411480"/>
           </a:xfrm>
           <a:prstGeom prst="rect">
             <a:avLst/>
@@ -6656,7 +6589,7 @@
           <a:lstStyle/>
           <a:p>
             <a:r>
-              <a:rPr sz="1400">
+              <a:rPr sz="1500">
                 <a:solidFill>
                   <a:srgbClr val="9496A1"/>
                 </a:solidFill>
@@ -6676,7 +6609,7 @@
         <p:spPr>
           <a:xfrm>
             <a:off x="685800" y="1874519"/>
-            <a:ext cx="7223760" cy="4297680"/>
+            <a:ext cx="7406640" cy="4389120"/>
           </a:xfrm>
           <a:prstGeom prst="rect">
             <a:avLst/>
@@ -6684,9 +6617,9 @@
           <a:solidFill>
             <a:srgbClr val="141418"/>
           </a:solidFill>
-          <a:ln w="11430">
+          <a:ln w="12700">
             <a:solidFill>
-              <a:srgbClr val="3D3E47"/>
+              <a:srgbClr val="3A3A42"/>
             </a:solidFill>
           </a:ln>
         </p:spPr>
@@ -6722,7 +6655,7 @@
         </p:nvGraphicFramePr>
         <p:xfrm>
           <a:off x="960120" y="2240280"/>
-          <a:ext cx="6720840" cy="3611880"/>
+          <a:ext cx="6903720" cy="3611880"/>
         </p:xfrm>
         <a:graphic>
           <a:graphicData uri="http://schemas.openxmlformats.org/drawingml/2006/chart">
@@ -6738,8 +6671,8 @@
         </p:nvSpPr>
         <p:spPr>
           <a:xfrm>
-            <a:off x="8183879" y="1874519"/>
-            <a:ext cx="3520440" cy="4297680"/>
+            <a:off x="8321040" y="1874519"/>
+            <a:ext cx="3383280" cy="4389120"/>
           </a:xfrm>
           <a:prstGeom prst="rect">
             <a:avLst/>
@@ -6747,9 +6680,9 @@
           <a:solidFill>
             <a:srgbClr val="1A1A1F"/>
           </a:solidFill>
-          <a:ln w="11430">
+          <a:ln w="12700">
             <a:solidFill>
-              <a:srgbClr val="3D3E47"/>
+              <a:srgbClr val="3A3A42"/>
             </a:solidFill>
           </a:ln>
         </p:spPr>
@@ -6783,8 +6716,8 @@
         </p:nvSpPr>
         <p:spPr>
           <a:xfrm>
-            <a:off x="8348471" y="2039111"/>
-            <a:ext cx="3200400" cy="3977640"/>
+            <a:off x="8595360" y="2240280"/>
+            <a:ext cx="2926080" cy="3566160"/>
           </a:xfrm>
           <a:prstGeom prst="rect">
             <a:avLst/>
@@ -6792,27 +6725,16 @@
           <a:noFill/>
         </p:spPr>
         <p:txBody>
-          <a:bodyPr wrap="none">
+          <a:bodyPr wrap="square">
             <a:spAutoFit/>
           </a:bodyPr>
           <a:lstStyle/>
           <a:p>
-            <a:r>
-              <a:rPr sz="1500" b="1">
-                <a:solidFill>
-                  <a:srgbClr val="C8922A"/>
-                </a:solidFill>
-                <a:latin typeface="Calibri"/>
-              </a:rPr>
-              <a:t>How this works in-app</a:t>
-            </a:r>
-          </a:p>
-          <a:p>
             <a:pPr>
               <a:spcAft>
-                <a:spcPts val="600"/>
+                <a:spcPts val="900"/>
               </a:spcAft>
-              <a:defRPr sz="1200">
+              <a:defRPr sz="1600" b="1">
                 <a:solidFill>
                   <a:srgbClr val="E8EAF0"/>
                 </a:solidFill>
@@ -6820,15 +6742,15 @@
               </a:defRPr>
             </a:pPr>
             <a:r>
-              <a:t>Bio-filter tags depleted hardware states first.</a:t>
+              <a:t>How Stillform applies this:</a:t>
             </a:r>
           </a:p>
           <a:p>
             <a:pPr>
               <a:spcAft>
-                <a:spcPts val="600"/>
+                <a:spcPts val="700"/>
               </a:spcAft>
-              <a:defRPr sz="1200">
+              <a:defRPr sz="1300" b="0">
                 <a:solidFill>
                   <a:srgbClr val="E8EAF0"/>
                 </a:solidFill>
@@ -6836,15 +6758,15 @@
               </a:defRPr>
             </a:pPr>
             <a:r>
-              <a:t>Reframe applies one microbias correction at a time.</a:t>
+              <a:t>Bio-filter marks depleted state before interpretation.</a:t>
             </a:r>
           </a:p>
           <a:p>
             <a:pPr>
               <a:spcAft>
-                <a:spcPts val="600"/>
+                <a:spcPts val="700"/>
               </a:spcAft>
-              <a:defRPr sz="1200">
+              <a:defRPr sz="1300" b="0">
                 <a:solidFill>
                   <a:srgbClr val="E8EAF0"/>
                 </a:solidFill>
@@ -6852,7 +6774,23 @@
               </a:defRPr>
             </a:pPr>
             <a:r>
-              <a:t>Goal: lower reactive conflict interpretation errors.</a:t>
+              <a:t>Reframe checks one microbias at a time (projection, attribution, contagion, impact gap, intensity).</a:t>
+            </a:r>
+          </a:p>
+          <a:p>
+            <a:pPr>
+              <a:spcAft>
+                <a:spcPts val="700"/>
+              </a:spcAft>
+              <a:defRPr sz="1300" b="0">
+                <a:solidFill>
+                  <a:srgbClr val="E8EAF0"/>
+                </a:solidFill>
+                <a:latin typeface="Calibri"/>
+              </a:defRPr>
+            </a:pPr>
+            <a:r>
+              <a:t>Target outcome: fewer avoidable social conflicts.</a:t>
             </a:r>
           </a:p>
         </p:txBody>
@@ -6866,7 +6804,7 @@
         <p:spPr>
           <a:xfrm>
             <a:off x="685800" y="6428232"/>
-            <a:ext cx="10972800" cy="228600"/>
+            <a:ext cx="10972800" cy="219456"/>
           </a:xfrm>
           <a:prstGeom prst="rect">
             <a:avLst/>
@@ -6880,13 +6818,13 @@
           <a:lstStyle/>
           <a:p>
             <a:r>
-              <a:rPr sz="800">
+              <a:rPr sz="850">
                 <a:solidFill>
                   <a:srgbClr val="9496A1"/>
                 </a:solidFill>
                 <a:latin typeface="Consolas"/>
               </a:rPr>
-              <a:t>Source: Stillform science sheet microbias section; Nature Communications 2025</a:t>
+              <a:t>Source: Stillform science sheet (microbias section); Nature Communications 2025</a:t>
             </a:r>
           </a:p>
         </p:txBody>
@@ -6969,7 +6907,7 @@
         <p:spPr>
           <a:xfrm>
             <a:off x="502920" y="100584"/>
-            <a:ext cx="7315200" cy="182880"/>
+            <a:ext cx="7772400" cy="182880"/>
           </a:xfrm>
           <a:prstGeom prst="rect">
             <a:avLst/>
@@ -6983,13 +6921,13 @@
           <a:lstStyle/>
           <a:p>
             <a:r>
-              <a:rPr sz="850">
+              <a:rPr sz="900">
                 <a:solidFill>
                   <a:srgbClr val="C8922A"/>
                 </a:solidFill>
                 <a:latin typeface="Consolas"/>
               </a:rPr>
-              <a:t>STILLFORM · APPLIED SCIENCE BRIEF</a:t>
+              <a:t>STILLFORM · EXECUTIVE APPLIED SCIENCE BRIEF</a:t>
             </a:r>
           </a:p>
         </p:txBody>
@@ -7002,8 +6940,8 @@
         </p:nvSpPr>
         <p:spPr>
           <a:xfrm>
-            <a:off x="10149840" y="100584"/>
-            <a:ext cx="1554480" cy="182880"/>
+            <a:off x="10241280" y="100584"/>
+            <a:ext cx="1463040" cy="182880"/>
           </a:xfrm>
           <a:prstGeom prst="rect">
             <a:avLst/>
@@ -7018,7 +6956,7 @@
           <a:p>
             <a:pPr algn="r"/>
             <a:r>
-              <a:rPr sz="850">
+              <a:rPr sz="900">
                 <a:solidFill>
                   <a:srgbClr val="9496A1"/>
                 </a:solidFill>
@@ -7038,7 +6976,7 @@
         <p:spPr>
           <a:xfrm>
             <a:off x="640080" y="640080"/>
-            <a:ext cx="10972800" cy="1005840"/>
+            <a:ext cx="10972800" cy="960120"/>
           </a:xfrm>
           <a:prstGeom prst="rect">
             <a:avLst/>
@@ -7052,7 +6990,7 @@
           <a:lstStyle/>
           <a:p>
             <a:r>
-              <a:rPr sz="3600" b="1">
+              <a:rPr sz="3800" b="1">
                 <a:solidFill>
                   <a:srgbClr val="E8EAF0"/>
                 </a:solidFill>
@@ -7071,8 +7009,8 @@
         </p:nvSpPr>
         <p:spPr>
           <a:xfrm>
-            <a:off x="658368" y="1417320"/>
-            <a:ext cx="10972800" cy="365760"/>
+            <a:off x="676656" y="1417320"/>
+            <a:ext cx="10881360" cy="411480"/>
           </a:xfrm>
           <a:prstGeom prst="rect">
             <a:avLst/>
@@ -7086,7 +7024,7 @@
           <a:lstStyle/>
           <a:p>
             <a:r>
-              <a:rPr sz="1400">
+              <a:rPr sz="1500">
                 <a:solidFill>
                   <a:srgbClr val="9496A1"/>
                 </a:solidFill>
@@ -7106,7 +7044,7 @@
         <p:spPr>
           <a:xfrm>
             <a:off x="685800" y="1874519"/>
-            <a:ext cx="5440680" cy="4297680"/>
+            <a:ext cx="5486400" cy="4389120"/>
           </a:xfrm>
           <a:prstGeom prst="rect">
             <a:avLst/>
@@ -7114,9 +7052,9 @@
           <a:solidFill>
             <a:srgbClr val="141418"/>
           </a:solidFill>
-          <a:ln w="11430">
+          <a:ln w="12700">
             <a:solidFill>
-              <a:srgbClr val="3D3E47"/>
+              <a:srgbClr val="3A3A42"/>
             </a:solidFill>
           </a:ln>
         </p:spPr>
@@ -7152,7 +7090,7 @@
         </p:nvGraphicFramePr>
         <p:xfrm>
           <a:off x="914400" y="2240280"/>
-          <a:ext cx="4983480" cy="3611880"/>
+          <a:ext cx="5074920" cy="3611880"/>
         </p:xfrm>
         <a:graphic>
           <a:graphicData uri="http://schemas.openxmlformats.org/drawingml/2006/chart">
@@ -7169,17 +7107,17 @@
         <p:spPr>
           <a:xfrm>
             <a:off x="6355080" y="1874519"/>
-            <a:ext cx="5349240" cy="2057400"/>
+            <a:ext cx="5349240" cy="4389120"/>
           </a:xfrm>
           <a:prstGeom prst="rect">
             <a:avLst/>
           </a:prstGeom>
           <a:solidFill>
-            <a:srgbClr val="141418"/>
+            <a:srgbClr val="1A1A1F"/>
           </a:solidFill>
-          <a:ln w="11430">
+          <a:ln w="12700">
             <a:solidFill>
-              <a:srgbClr val="3D3E47"/>
+              <a:srgbClr val="3A3A42"/>
             </a:solidFill>
           </a:ln>
         </p:spPr>
@@ -7214,8 +7152,8 @@
           <p:nvPr/>
         </p:nvGraphicFramePr>
         <p:xfrm>
-          <a:off x="6583680" y="2103120"/>
-          <a:ext cx="4892040" cy="1600200"/>
+          <a:off x="6583680" y="2240280"/>
+          <a:ext cx="2468880" cy="3611880"/>
         </p:xfrm>
         <a:graphic>
           <a:graphicData uri="http://schemas.openxmlformats.org/drawingml/2006/chart">
@@ -7225,59 +7163,14 @@
       </p:graphicFrame>
       <p:sp>
         <p:nvSpPr>
-          <p:cNvPr id="11" name="Rectangle 10"/>
-          <p:cNvSpPr/>
-          <p:nvPr/>
-        </p:nvSpPr>
-        <p:spPr>
-          <a:xfrm>
-            <a:off x="6355080" y="4114800"/>
-            <a:ext cx="5349240" cy="2057400"/>
-          </a:xfrm>
-          <a:prstGeom prst="rect">
-            <a:avLst/>
-          </a:prstGeom>
-          <a:solidFill>
-            <a:srgbClr val="1A1A1F"/>
-          </a:solidFill>
-          <a:ln w="11430">
-            <a:solidFill>
-              <a:srgbClr val="3D3E47"/>
-            </a:solidFill>
-          </a:ln>
-        </p:spPr>
-        <p:style>
-          <a:lnRef idx="1">
-            <a:schemeClr val="accent1"/>
-          </a:lnRef>
-          <a:fillRef idx="3">
-            <a:schemeClr val="accent1"/>
-          </a:fillRef>
-          <a:effectRef idx="2">
-            <a:schemeClr val="accent1"/>
-          </a:effectRef>
-          <a:fontRef idx="minor">
-            <a:schemeClr val="lt1"/>
-          </a:fontRef>
-        </p:style>
-        <p:txBody>
-          <a:bodyPr rtlCol="0" anchor="ctr"/>
-          <a:lstStyle/>
-          <a:p>
-            <a:pPr algn="ctr"/>
-          </a:p>
-        </p:txBody>
-      </p:sp>
-      <p:sp>
-        <p:nvSpPr>
-          <p:cNvPr id="12" name="TextBox 11"/>
+          <p:cNvPr id="11" name="TextBox 10"/>
           <p:cNvSpPr txBox="1"/>
           <p:nvPr/>
         </p:nvSpPr>
         <p:spPr>
           <a:xfrm>
-            <a:off x="6519672" y="4279392"/>
-            <a:ext cx="5029200" cy="1737360"/>
+            <a:off x="9326880" y="2240280"/>
+            <a:ext cx="2240280" cy="3566160"/>
           </a:xfrm>
           <a:prstGeom prst="rect">
             <a:avLst/>
@@ -7285,27 +7178,16 @@
           <a:noFill/>
         </p:spPr>
         <p:txBody>
-          <a:bodyPr wrap="none">
+          <a:bodyPr wrap="square">
             <a:spAutoFit/>
           </a:bodyPr>
           <a:lstStyle/>
           <a:p>
-            <a:r>
-              <a:rPr sz="1500" b="1">
-                <a:solidFill>
-                  <a:srgbClr val="C8922A"/>
-                </a:solidFill>
-                <a:latin typeface="Calibri"/>
-              </a:rPr>
-              <a:t>How this works in-app</a:t>
-            </a:r>
-          </a:p>
-          <a:p>
             <a:pPr>
               <a:spcAft>
-                <a:spcPts val="600"/>
+                <a:spcPts val="900"/>
               </a:spcAft>
-              <a:defRPr sz="1200">
+              <a:defRPr sz="1500" b="1">
                 <a:solidFill>
                   <a:srgbClr val="E8EAF0"/>
                 </a:solidFill>
@@ -7313,15 +7195,15 @@
               </a:defRPr>
             </a:pPr>
             <a:r>
-              <a:t>Somatic interrupt catches rapid escalation in-session.</a:t>
+              <a:t>How Stillform applies this:</a:t>
             </a:r>
           </a:p>
           <a:p>
             <a:pPr>
               <a:spcAft>
-                <a:spcPts val="600"/>
+                <a:spcPts val="700"/>
               </a:spcAft>
-              <a:defRPr sz="1200">
+              <a:defRPr sz="1250" b="0">
                 <a:solidFill>
                   <a:srgbClr val="E8EAF0"/>
                 </a:solidFill>
@@ -7329,15 +7211,15 @@
               </a:defRPr>
             </a:pPr>
             <a:r>
-              <a:t>Default pathway routing reduces decision lag under load.</a:t>
+              <a:t>Somatic interrupt catches body escalation during Reframe.</a:t>
             </a:r>
           </a:p>
           <a:p>
             <a:pPr>
               <a:spcAft>
-                <a:spcPts val="600"/>
+                <a:spcPts val="700"/>
               </a:spcAft>
-              <a:defRPr sz="1200">
+              <a:defRPr sz="1250" b="0">
                 <a:solidFill>
                   <a:srgbClr val="E8EAF0"/>
                 </a:solidFill>
@@ -7345,21 +7227,37 @@
               </a:defRPr>
             </a:pPr>
             <a:r>
-              <a:t>Target: reduce reactive action in high-pressure windows.</a:t>
-            </a:r>
-          </a:p>
-        </p:txBody>
-      </p:sp>
-      <p:sp>
-        <p:nvSpPr>
-          <p:cNvPr id="13" name="TextBox 12"/>
+              <a:t>Default pathway routing removes decision delay in high arousal.</a:t>
+            </a:r>
+          </a:p>
+          <a:p>
+            <a:pPr>
+              <a:spcAft>
+                <a:spcPts val="700"/>
+              </a:spcAft>
+              <a:defRPr sz="1250" b="0">
+                <a:solidFill>
+                  <a:srgbClr val="E8EAF0"/>
+                </a:solidFill>
+                <a:latin typeface="Calibri"/>
+              </a:defRPr>
+            </a:pPr>
+            <a:r>
+              <a:t>Measured by faster stabilization and stronger post-shift scores.</a:t>
+            </a:r>
+          </a:p>
+        </p:txBody>
+      </p:sp>
+      <p:sp>
+        <p:nvSpPr>
+          <p:cNvPr id="12" name="TextBox 11"/>
           <p:cNvSpPr txBox="1"/>
           <p:nvPr/>
         </p:nvSpPr>
         <p:spPr>
           <a:xfrm>
             <a:off x="685800" y="6428232"/>
-            <a:ext cx="10972800" cy="228600"/>
+            <a:ext cx="10972800" cy="219456"/>
           </a:xfrm>
           <a:prstGeom prst="rect">
             <a:avLst/>
@@ -7373,13 +7271,13 @@
           <a:lstStyle/>
           <a:p>
             <a:r>
-              <a:rPr sz="800">
+              <a:rPr sz="850">
                 <a:solidFill>
                   <a:srgbClr val="9496A1"/>
                 </a:solidFill>
                 <a:latin typeface="Consolas"/>
               </a:rPr>
-              <a:t>Source: Gallup 2024/2025 context; Stillform somatic interrupt + routing logic</a:t>
+              <a:t>Source: Gallup 2025 contextual trend references; Stillform intervention flow</a:t>
             </a:r>
           </a:p>
         </p:txBody>
@@ -7462,7 +7360,7 @@
         <p:spPr>
           <a:xfrm>
             <a:off x="502920" y="100584"/>
-            <a:ext cx="7315200" cy="182880"/>
+            <a:ext cx="7772400" cy="182880"/>
           </a:xfrm>
           <a:prstGeom prst="rect">
             <a:avLst/>
@@ -7476,13 +7374,13 @@
           <a:lstStyle/>
           <a:p>
             <a:r>
-              <a:rPr sz="850">
+              <a:rPr sz="900">
                 <a:solidFill>
                   <a:srgbClr val="C8922A"/>
                 </a:solidFill>
                 <a:latin typeface="Consolas"/>
               </a:rPr>
-              <a:t>STILLFORM · APPLIED SCIENCE BRIEF</a:t>
+              <a:t>STILLFORM · EXECUTIVE APPLIED SCIENCE BRIEF</a:t>
             </a:r>
           </a:p>
         </p:txBody>
@@ -7495,8 +7393,8 @@
         </p:nvSpPr>
         <p:spPr>
           <a:xfrm>
-            <a:off x="10149840" y="100584"/>
-            <a:ext cx="1554480" cy="182880"/>
+            <a:off x="10241280" y="100584"/>
+            <a:ext cx="1463040" cy="182880"/>
           </a:xfrm>
           <a:prstGeom prst="rect">
             <a:avLst/>
@@ -7511,7 +7409,7 @@
           <a:p>
             <a:pPr algn="r"/>
             <a:r>
-              <a:rPr sz="850">
+              <a:rPr sz="900">
                 <a:solidFill>
                   <a:srgbClr val="9496A1"/>
                 </a:solidFill>
@@ -7531,7 +7429,7 @@
         <p:spPr>
           <a:xfrm>
             <a:off x="640080" y="640080"/>
-            <a:ext cx="10972800" cy="1005840"/>
+            <a:ext cx="10972800" cy="960120"/>
           </a:xfrm>
           <a:prstGeom prst="rect">
             <a:avLst/>
@@ -7545,13 +7443,13 @@
           <a:lstStyle/>
           <a:p>
             <a:r>
-              <a:rPr sz="3600" b="1">
+              <a:rPr sz="3800" b="1">
                 <a:solidFill>
                   <a:srgbClr val="E8EAF0"/>
                 </a:solidFill>
                 <a:latin typeface="Calibri"/>
               </a:rPr>
-              <a:t>Stillform Mechanism</a:t>
+              <a:t>How Stillform Works</a:t>
             </a:r>
           </a:p>
         </p:txBody>
@@ -7564,8 +7462,8 @@
         </p:nvSpPr>
         <p:spPr>
           <a:xfrm>
-            <a:off x="658368" y="1417320"/>
-            <a:ext cx="10972800" cy="365760"/>
+            <a:off x="676656" y="1417320"/>
+            <a:ext cx="10881360" cy="411480"/>
           </a:xfrm>
           <a:prstGeom prst="rect">
             <a:avLst/>
@@ -7579,13 +7477,13 @@
           <a:lstStyle/>
           <a:p>
             <a:r>
-              <a:rPr sz="1400">
+              <a:rPr sz="1500">
                 <a:solidFill>
                   <a:srgbClr val="9496A1"/>
                 </a:solidFill>
                 <a:latin typeface="Calibri"/>
               </a:rPr>
-              <a:t>Daily operating loop</a:t>
+              <a:t>Applied science translated into one daily operating loop</a:t>
             </a:r>
           </a:p>
         </p:txBody>
@@ -7598,8 +7496,8 @@
         </p:nvSpPr>
         <p:spPr>
           <a:xfrm>
-            <a:off x="658368" y="2240280"/>
-            <a:ext cx="2176272" cy="2560320"/>
+            <a:off x="658368" y="2148840"/>
+            <a:ext cx="2240280" cy="2697480"/>
           </a:xfrm>
           <a:prstGeom prst="rect">
             <a:avLst/>
@@ -7607,9 +7505,9 @@
           <a:solidFill>
             <a:srgbClr val="141418"/>
           </a:solidFill>
-          <a:ln w="11430">
+          <a:ln w="12700">
             <a:solidFill>
-              <a:srgbClr val="3D3E47"/>
+              <a:srgbClr val="3A3A42"/>
             </a:solidFill>
           </a:ln>
         </p:spPr>
@@ -7643,8 +7541,8 @@
         </p:nvSpPr>
         <p:spPr>
           <a:xfrm>
-            <a:off x="804672" y="2423160"/>
-            <a:ext cx="1874519" cy="502920"/>
+            <a:off x="795528" y="2313432"/>
+            <a:ext cx="1920240" cy="457200"/>
           </a:xfrm>
           <a:prstGeom prst="rect">
             <a:avLst/>
@@ -7658,7 +7556,7 @@
           <a:lstStyle/>
           <a:p>
             <a:r>
-              <a:rPr sz="1400" b="1">
+              <a:rPr sz="1500" b="1">
                 <a:solidFill>
                   <a:srgbClr val="C8922A"/>
                 </a:solidFill>
@@ -7671,23 +7569,59 @@
       </p:sp>
       <p:sp>
         <p:nvSpPr>
-          <p:cNvPr id="9" name="Right Arrow 8"/>
+          <p:cNvPr id="9" name="TextBox 8"/>
+          <p:cNvSpPr txBox="1"/>
+          <p:nvPr/>
+        </p:nvSpPr>
+        <p:spPr>
+          <a:xfrm>
+            <a:off x="795528" y="2935224"/>
+            <a:ext cx="1920240" cy="1783080"/>
+          </a:xfrm>
+          <a:prstGeom prst="rect">
+            <a:avLst/>
+          </a:prstGeom>
+          <a:noFill/>
+        </p:spPr>
+        <p:txBody>
+          <a:bodyPr wrap="none">
+            <a:spAutoFit/>
+          </a:bodyPr>
+          <a:lstStyle/>
+          <a:p>
+            <a:r>
+              <a:rPr sz="1300">
+                <a:solidFill>
+                  <a:srgbClr val="E8EAF0"/>
+                </a:solidFill>
+                <a:latin typeface="Calibri"/>
+              </a:rPr>
+              <a:t>Morning check-in + bio-filter</a:t>
+            </a:r>
+          </a:p>
+        </p:txBody>
+      </p:sp>
+      <p:sp>
+        <p:nvSpPr>
+          <p:cNvPr id="10" name="Rectangle 9"/>
           <p:cNvSpPr/>
           <p:nvPr/>
         </p:nvSpPr>
         <p:spPr>
           <a:xfrm>
-            <a:off x="2816352" y="3246120"/>
-            <a:ext cx="128016" cy="457200"/>
-          </a:xfrm>
-          <a:prstGeom prst="rightArrow">
+            <a:off x="2990088" y="2148840"/>
+            <a:ext cx="2240280" cy="2697480"/>
+          </a:xfrm>
+          <a:prstGeom prst="rect">
             <a:avLst/>
           </a:prstGeom>
           <a:solidFill>
-            <a:srgbClr val="9496A1"/>
+            <a:srgbClr val="1A1A1F"/>
           </a:solidFill>
-          <a:ln>
-            <a:noFill/>
+          <a:ln w="12700">
+            <a:solidFill>
+              <a:srgbClr val="3A3A42"/>
+            </a:solidFill>
           </a:ln>
         </p:spPr>
         <p:style>
@@ -7714,24 +7648,92 @@
       </p:sp>
       <p:sp>
         <p:nvSpPr>
-          <p:cNvPr id="10" name="Rectangle 9"/>
+          <p:cNvPr id="11" name="TextBox 10"/>
+          <p:cNvSpPr txBox="1"/>
+          <p:nvPr/>
+        </p:nvSpPr>
+        <p:spPr>
+          <a:xfrm>
+            <a:off x="3127248" y="2313432"/>
+            <a:ext cx="1920240" cy="457200"/>
+          </a:xfrm>
+          <a:prstGeom prst="rect">
+            <a:avLst/>
+          </a:prstGeom>
+          <a:noFill/>
+        </p:spPr>
+        <p:txBody>
+          <a:bodyPr wrap="none">
+            <a:spAutoFit/>
+          </a:bodyPr>
+          <a:lstStyle/>
+          <a:p>
+            <a:r>
+              <a:rPr sz="1500" b="1">
+                <a:solidFill>
+                  <a:srgbClr val="C8922A"/>
+                </a:solidFill>
+                <a:latin typeface="Calibri"/>
+              </a:rPr>
+              <a:t>Interrupt</a:t>
+            </a:r>
+          </a:p>
+        </p:txBody>
+      </p:sp>
+      <p:sp>
+        <p:nvSpPr>
+          <p:cNvPr id="12" name="TextBox 11"/>
+          <p:cNvSpPr txBox="1"/>
+          <p:nvPr/>
+        </p:nvSpPr>
+        <p:spPr>
+          <a:xfrm>
+            <a:off x="3127248" y="2935224"/>
+            <a:ext cx="1920240" cy="1783080"/>
+          </a:xfrm>
+          <a:prstGeom prst="rect">
+            <a:avLst/>
+          </a:prstGeom>
+          <a:noFill/>
+        </p:spPr>
+        <p:txBody>
+          <a:bodyPr wrap="none">
+            <a:spAutoFit/>
+          </a:bodyPr>
+          <a:lstStyle/>
+          <a:p>
+            <a:r>
+              <a:rPr sz="1300">
+                <a:solidFill>
+                  <a:srgbClr val="E8EAF0"/>
+                </a:solidFill>
+                <a:latin typeface="Calibri"/>
+              </a:rPr>
+              <a:t>Breathe / Body Scan / somatic cue</a:t>
+            </a:r>
+          </a:p>
+        </p:txBody>
+      </p:sp>
+      <p:sp>
+        <p:nvSpPr>
+          <p:cNvPr id="13" name="Rectangle 12"/>
           <p:cNvSpPr/>
           <p:nvPr/>
         </p:nvSpPr>
         <p:spPr>
           <a:xfrm>
-            <a:off x="2944368" y="2240280"/>
-            <a:ext cx="2176272" cy="2560320"/>
+            <a:off x="5321808" y="2148840"/>
+            <a:ext cx="2240280" cy="2697480"/>
           </a:xfrm>
           <a:prstGeom prst="rect">
             <a:avLst/>
           </a:prstGeom>
           <a:solidFill>
-            <a:srgbClr val="1A1A1F"/>
+            <a:srgbClr val="141418"/>
           </a:solidFill>
-          <a:ln w="11430">
+          <a:ln w="12700">
             <a:solidFill>
-              <a:srgbClr val="3D3E47"/>
+              <a:srgbClr val="3A3A42"/>
             </a:solidFill>
           </a:ln>
         </p:spPr>
@@ -7759,14 +7761,14 @@
       </p:sp>
       <p:sp>
         <p:nvSpPr>
-          <p:cNvPr id="11" name="TextBox 10"/>
+          <p:cNvPr id="14" name="TextBox 13"/>
           <p:cNvSpPr txBox="1"/>
           <p:nvPr/>
         </p:nvSpPr>
         <p:spPr>
           <a:xfrm>
-            <a:off x="3090672" y="2423160"/>
-            <a:ext cx="1874519" cy="502920"/>
+            <a:off x="5458968" y="2313432"/>
+            <a:ext cx="1920240" cy="457200"/>
           </a:xfrm>
           <a:prstGeom prst="rect">
             <a:avLst/>
@@ -7780,36 +7782,72 @@
           <a:lstStyle/>
           <a:p>
             <a:r>
-              <a:rPr sz="1400" b="1">
+              <a:rPr sz="1500" b="1">
                 <a:solidFill>
                   <a:srgbClr val="C8922A"/>
                 </a:solidFill>
                 <a:latin typeface="Calibri"/>
               </a:rPr>
-              <a:t>Intervention</a:t>
-            </a:r>
-          </a:p>
-        </p:txBody>
-      </p:sp>
-      <p:sp>
-        <p:nvSpPr>
-          <p:cNvPr id="12" name="Right Arrow 11"/>
+              <a:t>Reframe</a:t>
+            </a:r>
+          </a:p>
+        </p:txBody>
+      </p:sp>
+      <p:sp>
+        <p:nvSpPr>
+          <p:cNvPr id="15" name="TextBox 14"/>
+          <p:cNvSpPr txBox="1"/>
+          <p:nvPr/>
+        </p:nvSpPr>
+        <p:spPr>
+          <a:xfrm>
+            <a:off x="5458968" y="2935224"/>
+            <a:ext cx="1920240" cy="1783080"/>
+          </a:xfrm>
+          <a:prstGeom prst="rect">
+            <a:avLst/>
+          </a:prstGeom>
+          <a:noFill/>
+        </p:spPr>
+        <p:txBody>
+          <a:bodyPr wrap="none">
+            <a:spAutoFit/>
+          </a:bodyPr>
+          <a:lstStyle/>
+          <a:p>
+            <a:r>
+              <a:rPr sz="1300">
+                <a:solidFill>
+                  <a:srgbClr val="E8EAF0"/>
+                </a:solidFill>
+                <a:latin typeface="Calibri"/>
+              </a:rPr>
+              <a:t>Structured cognitive shift + microbias check</a:t>
+            </a:r>
+          </a:p>
+        </p:txBody>
+      </p:sp>
+      <p:sp>
+        <p:nvSpPr>
+          <p:cNvPr id="16" name="Rectangle 15"/>
           <p:cNvSpPr/>
           <p:nvPr/>
         </p:nvSpPr>
         <p:spPr>
           <a:xfrm>
-            <a:off x="5102352" y="3246120"/>
-            <a:ext cx="128016" cy="457200"/>
-          </a:xfrm>
-          <a:prstGeom prst="rightArrow">
+            <a:off x="7653528" y="2148840"/>
+            <a:ext cx="2240280" cy="2697480"/>
+          </a:xfrm>
+          <a:prstGeom prst="rect">
             <a:avLst/>
           </a:prstGeom>
           <a:solidFill>
-            <a:srgbClr val="9496A1"/>
+            <a:srgbClr val="1A1A1F"/>
           </a:solidFill>
-          <a:ln>
-            <a:noFill/>
+          <a:ln w="12700">
+            <a:solidFill>
+              <a:srgbClr val="3A3A42"/>
+            </a:solidFill>
           </a:ln>
         </p:spPr>
         <p:style>
@@ -7836,14 +7874,82 @@
       </p:sp>
       <p:sp>
         <p:nvSpPr>
-          <p:cNvPr id="13" name="Rectangle 12"/>
+          <p:cNvPr id="17" name="TextBox 16"/>
+          <p:cNvSpPr txBox="1"/>
+          <p:nvPr/>
+        </p:nvSpPr>
+        <p:spPr>
+          <a:xfrm>
+            <a:off x="7790688" y="2313432"/>
+            <a:ext cx="1920240" cy="457200"/>
+          </a:xfrm>
+          <a:prstGeom prst="rect">
+            <a:avLst/>
+          </a:prstGeom>
+          <a:noFill/>
+        </p:spPr>
+        <p:txBody>
+          <a:bodyPr wrap="none">
+            <a:spAutoFit/>
+          </a:bodyPr>
+          <a:lstStyle/>
+          <a:p>
+            <a:r>
+              <a:rPr sz="1500" b="1">
+                <a:solidFill>
+                  <a:srgbClr val="C8922A"/>
+                </a:solidFill>
+                <a:latin typeface="Calibri"/>
+              </a:rPr>
+              <a:t>Rate shift</a:t>
+            </a:r>
+          </a:p>
+        </p:txBody>
+      </p:sp>
+      <p:sp>
+        <p:nvSpPr>
+          <p:cNvPr id="18" name="TextBox 17"/>
+          <p:cNvSpPr txBox="1"/>
+          <p:nvPr/>
+        </p:nvSpPr>
+        <p:spPr>
+          <a:xfrm>
+            <a:off x="7790688" y="2935224"/>
+            <a:ext cx="1920240" cy="1783080"/>
+          </a:xfrm>
+          <a:prstGeom prst="rect">
+            <a:avLst/>
+          </a:prstGeom>
+          <a:noFill/>
+        </p:spPr>
+        <p:txBody>
+          <a:bodyPr wrap="none">
+            <a:spAutoFit/>
+          </a:bodyPr>
+          <a:lstStyle/>
+          <a:p>
+            <a:r>
+              <a:rPr sz="1300">
+                <a:solidFill>
+                  <a:srgbClr val="E8EAF0"/>
+                </a:solidFill>
+                <a:latin typeface="Calibri"/>
+              </a:rPr>
+              <a:t>Non-skippable post-session state rating</a:t>
+            </a:r>
+          </a:p>
+        </p:txBody>
+      </p:sp>
+      <p:sp>
+        <p:nvSpPr>
+          <p:cNvPr id="19" name="Rectangle 18"/>
           <p:cNvSpPr/>
           <p:nvPr/>
         </p:nvSpPr>
         <p:spPr>
           <a:xfrm>
-            <a:off x="5230368" y="2240280"/>
-            <a:ext cx="2176272" cy="2560320"/>
+            <a:off x="9985248" y="2148840"/>
+            <a:ext cx="2240280" cy="2697480"/>
           </a:xfrm>
           <a:prstGeom prst="rect">
             <a:avLst/>
@@ -7851,9 +7957,9 @@
           <a:solidFill>
             <a:srgbClr val="141418"/>
           </a:solidFill>
-          <a:ln w="11430">
+          <a:ln w="12700">
             <a:solidFill>
-              <a:srgbClr val="3D3E47"/>
+              <a:srgbClr val="3A3A42"/>
             </a:solidFill>
           </a:ln>
         </p:spPr>
@@ -7881,14 +7987,14 @@
       </p:sp>
       <p:sp>
         <p:nvSpPr>
-          <p:cNvPr id="14" name="TextBox 13"/>
+          <p:cNvPr id="20" name="TextBox 19"/>
           <p:cNvSpPr txBox="1"/>
           <p:nvPr/>
         </p:nvSpPr>
         <p:spPr>
           <a:xfrm>
-            <a:off x="5376672" y="2423160"/>
-            <a:ext cx="1874519" cy="502920"/>
+            <a:off x="10122408" y="2313432"/>
+            <a:ext cx="1920240" cy="457200"/>
           </a:xfrm>
           <a:prstGeom prst="rect">
             <a:avLst/>
@@ -7902,115 +8008,27 @@
           <a:lstStyle/>
           <a:p>
             <a:r>
-              <a:rPr sz="1400" b="1">
+              <a:rPr sz="1500" b="1">
                 <a:solidFill>
                   <a:srgbClr val="C8922A"/>
                 </a:solidFill>
                 <a:latin typeface="Calibri"/>
               </a:rPr>
-              <a:t>Reappraisal</a:t>
-            </a:r>
-          </a:p>
-        </p:txBody>
-      </p:sp>
-      <p:sp>
-        <p:nvSpPr>
-          <p:cNvPr id="15" name="Right Arrow 14"/>
-          <p:cNvSpPr/>
-          <p:nvPr/>
-        </p:nvSpPr>
-        <p:spPr>
-          <a:xfrm>
-            <a:off x="7388352" y="3246120"/>
-            <a:ext cx="128016" cy="457200"/>
-          </a:xfrm>
-          <a:prstGeom prst="rightArrow">
-            <a:avLst/>
-          </a:prstGeom>
-          <a:solidFill>
-            <a:srgbClr val="9496A1"/>
-          </a:solidFill>
-          <a:ln>
-            <a:noFill/>
-          </a:ln>
-        </p:spPr>
-        <p:style>
-          <a:lnRef idx="1">
-            <a:schemeClr val="accent1"/>
-          </a:lnRef>
-          <a:fillRef idx="3">
-            <a:schemeClr val="accent1"/>
-          </a:fillRef>
-          <a:effectRef idx="2">
-            <a:schemeClr val="accent1"/>
-          </a:effectRef>
-          <a:fontRef idx="minor">
-            <a:schemeClr val="lt1"/>
-          </a:fontRef>
-        </p:style>
-        <p:txBody>
-          <a:bodyPr rtlCol="0" anchor="ctr"/>
-          <a:lstStyle/>
-          <a:p>
-            <a:pPr algn="ctr"/>
-          </a:p>
-        </p:txBody>
-      </p:sp>
-      <p:sp>
-        <p:nvSpPr>
-          <p:cNvPr id="16" name="Rectangle 15"/>
-          <p:cNvSpPr/>
-          <p:nvPr/>
-        </p:nvSpPr>
-        <p:spPr>
-          <a:xfrm>
-            <a:off x="7516368" y="2240280"/>
-            <a:ext cx="2176272" cy="2560320"/>
-          </a:xfrm>
-          <a:prstGeom prst="rect">
-            <a:avLst/>
-          </a:prstGeom>
-          <a:solidFill>
-            <a:srgbClr val="1A1A1F"/>
-          </a:solidFill>
-          <a:ln w="11430">
-            <a:solidFill>
-              <a:srgbClr val="3D3E47"/>
-            </a:solidFill>
-          </a:ln>
-        </p:spPr>
-        <p:style>
-          <a:lnRef idx="1">
-            <a:schemeClr val="accent1"/>
-          </a:lnRef>
-          <a:fillRef idx="3">
-            <a:schemeClr val="accent1"/>
-          </a:fillRef>
-          <a:effectRef idx="2">
-            <a:schemeClr val="accent1"/>
-          </a:effectRef>
-          <a:fontRef idx="minor">
-            <a:schemeClr val="lt1"/>
-          </a:fontRef>
-        </p:style>
-        <p:txBody>
-          <a:bodyPr rtlCol="0" anchor="ctr"/>
-          <a:lstStyle/>
-          <a:p>
-            <a:pPr algn="ctr"/>
-          </a:p>
-        </p:txBody>
-      </p:sp>
-      <p:sp>
-        <p:nvSpPr>
-          <p:cNvPr id="17" name="TextBox 16"/>
+              <a:t>Close loop</a:t>
+            </a:r>
+          </a:p>
+        </p:txBody>
+      </p:sp>
+      <p:sp>
+        <p:nvSpPr>
+          <p:cNvPr id="21" name="TextBox 20"/>
           <p:cNvSpPr txBox="1"/>
           <p:nvPr/>
         </p:nvSpPr>
         <p:spPr>
           <a:xfrm>
-            <a:off x="7662672" y="2423160"/>
-            <a:ext cx="1874519" cy="502920"/>
+            <a:off x="10122408" y="2935224"/>
+            <a:ext cx="1920240" cy="1783080"/>
           </a:xfrm>
           <a:prstGeom prst="rect">
             <a:avLst/>
@@ -8024,115 +8042,27 @@
           <a:lstStyle/>
           <a:p>
             <a:r>
-              <a:rPr sz="1400" b="1">
-                <a:solidFill>
-                  <a:srgbClr val="C8922A"/>
+              <a:rPr sz="1300">
+                <a:solidFill>
+                  <a:srgbClr val="E8EAF0"/>
                 </a:solidFill>
                 <a:latin typeface="Calibri"/>
               </a:rPr>
-              <a:t>Transfer action</a:t>
-            </a:r>
-          </a:p>
-        </p:txBody>
-      </p:sp>
-      <p:sp>
-        <p:nvSpPr>
-          <p:cNvPr id="18" name="Right Arrow 17"/>
-          <p:cNvSpPr/>
-          <p:nvPr/>
-        </p:nvSpPr>
-        <p:spPr>
-          <a:xfrm>
-            <a:off x="9674352" y="3246120"/>
-            <a:ext cx="128016" cy="457200"/>
-          </a:xfrm>
-          <a:prstGeom prst="rightArrow">
-            <a:avLst/>
-          </a:prstGeom>
-          <a:solidFill>
-            <a:srgbClr val="9496A1"/>
-          </a:solidFill>
-          <a:ln>
-            <a:noFill/>
-          </a:ln>
-        </p:spPr>
-        <p:style>
-          <a:lnRef idx="1">
-            <a:schemeClr val="accent1"/>
-          </a:lnRef>
-          <a:fillRef idx="3">
-            <a:schemeClr val="accent1"/>
-          </a:fillRef>
-          <a:effectRef idx="2">
-            <a:schemeClr val="accent1"/>
-          </a:effectRef>
-          <a:fontRef idx="minor">
-            <a:schemeClr val="lt1"/>
-          </a:fontRef>
-        </p:style>
-        <p:txBody>
-          <a:bodyPr rtlCol="0" anchor="ctr"/>
-          <a:lstStyle/>
-          <a:p>
-            <a:pPr algn="ctr"/>
-          </a:p>
-        </p:txBody>
-      </p:sp>
-      <p:sp>
-        <p:nvSpPr>
-          <p:cNvPr id="19" name="Rectangle 18"/>
-          <p:cNvSpPr/>
-          <p:nvPr/>
-        </p:nvSpPr>
-        <p:spPr>
-          <a:xfrm>
-            <a:off x="9802368" y="2240280"/>
-            <a:ext cx="2176272" cy="2560320"/>
-          </a:xfrm>
-          <a:prstGeom prst="rect">
-            <a:avLst/>
-          </a:prstGeom>
-          <a:solidFill>
-            <a:srgbClr val="141418"/>
-          </a:solidFill>
-          <a:ln w="11430">
-            <a:solidFill>
-              <a:srgbClr val="3D3E47"/>
-            </a:solidFill>
-          </a:ln>
-        </p:spPr>
-        <p:style>
-          <a:lnRef idx="1">
-            <a:schemeClr val="accent1"/>
-          </a:lnRef>
-          <a:fillRef idx="3">
-            <a:schemeClr val="accent1"/>
-          </a:fillRef>
-          <a:effectRef idx="2">
-            <a:schemeClr val="accent1"/>
-          </a:effectRef>
-          <a:fontRef idx="minor">
-            <a:schemeClr val="lt1"/>
-          </a:fontRef>
-        </p:style>
-        <p:txBody>
-          <a:bodyPr rtlCol="0" anchor="ctr"/>
-          <a:lstStyle/>
-          <a:p>
-            <a:pPr algn="ctr"/>
-          </a:p>
-        </p:txBody>
-      </p:sp>
-      <p:sp>
-        <p:nvSpPr>
-          <p:cNvPr id="20" name="TextBox 19"/>
+              <a:t>EOD check-in feeds next-day context</a:t>
+            </a:r>
+          </a:p>
+        </p:txBody>
+      </p:sp>
+      <p:sp>
+        <p:nvSpPr>
+          <p:cNvPr id="22" name="TextBox 21"/>
           <p:cNvSpPr txBox="1"/>
           <p:nvPr/>
         </p:nvSpPr>
         <p:spPr>
           <a:xfrm>
-            <a:off x="9948672" y="2423160"/>
-            <a:ext cx="1874519" cy="502920"/>
+            <a:off x="685800" y="6428232"/>
+            <a:ext cx="10972800" cy="219456"/>
           </a:xfrm>
           <a:prstGeom prst="rect">
             <a:avLst/>
@@ -8146,142 +8076,13 @@
           <a:lstStyle/>
           <a:p>
             <a:r>
-              <a:rPr sz="1400" b="1">
-                <a:solidFill>
-                  <a:srgbClr val="C8922A"/>
-                </a:solidFill>
-                <a:latin typeface="Calibri"/>
-              </a:rPr>
-              <a:t>EOD consolidation</a:t>
-            </a:r>
-          </a:p>
-        </p:txBody>
-      </p:sp>
-      <p:sp>
-        <p:nvSpPr>
-          <p:cNvPr id="21" name="Rectangle 20"/>
-          <p:cNvSpPr/>
-          <p:nvPr/>
-        </p:nvSpPr>
-        <p:spPr>
-          <a:xfrm>
-            <a:off x="658368" y="4983480"/>
-            <a:ext cx="11027664" cy="1188720"/>
-          </a:xfrm>
-          <a:prstGeom prst="rect">
-            <a:avLst/>
-          </a:prstGeom>
-          <a:solidFill>
-            <a:srgbClr val="1A1A1F"/>
-          </a:solidFill>
-          <a:ln w="11430">
-            <a:solidFill>
-              <a:srgbClr val="3D3E47"/>
-            </a:solidFill>
-          </a:ln>
-        </p:spPr>
-        <p:style>
-          <a:lnRef idx="1">
-            <a:schemeClr val="accent1"/>
-          </a:lnRef>
-          <a:fillRef idx="3">
-            <a:schemeClr val="accent1"/>
-          </a:fillRef>
-          <a:effectRef idx="2">
-            <a:schemeClr val="accent1"/>
-          </a:effectRef>
-          <a:fontRef idx="minor">
-            <a:schemeClr val="lt1"/>
-          </a:fontRef>
-        </p:style>
-        <p:txBody>
-          <a:bodyPr rtlCol="0" anchor="ctr"/>
-          <a:lstStyle/>
-          <a:p>
-            <a:pPr algn="ctr"/>
-          </a:p>
-        </p:txBody>
-      </p:sp>
-      <p:sp>
-        <p:nvSpPr>
-          <p:cNvPr id="22" name="TextBox 21"/>
-          <p:cNvSpPr txBox="1"/>
-          <p:nvPr/>
-        </p:nvSpPr>
-        <p:spPr>
-          <a:xfrm>
-            <a:off x="822960" y="5148072"/>
-            <a:ext cx="10707624" cy="868680"/>
-          </a:xfrm>
-          <a:prstGeom prst="rect">
-            <a:avLst/>
-          </a:prstGeom>
-          <a:noFill/>
-        </p:spPr>
-        <p:txBody>
-          <a:bodyPr wrap="none">
-            <a:spAutoFit/>
-          </a:bodyPr>
-          <a:lstStyle/>
-          <a:p>
-            <a:r>
-              <a:rPr sz="1500" b="1">
-                <a:solidFill>
-                  <a:srgbClr val="C8922A"/>
-                </a:solidFill>
-                <a:latin typeface="Calibri"/>
-              </a:rPr>
-              <a:t>Execution intent</a:t>
-            </a:r>
-          </a:p>
-          <a:p>
-            <a:pPr>
-              <a:spcAft>
-                <a:spcPts val="600"/>
-              </a:spcAft>
-              <a:defRPr sz="1200">
-                <a:solidFill>
-                  <a:srgbClr val="E8EAF0"/>
-                </a:solidFill>
-                <a:latin typeface="Calibri"/>
-              </a:defRPr>
-            </a:pPr>
-            <a:r>
-              <a:t>Composure is trained as repeatable daily behavior, not occasional mood relief.</a:t>
-            </a:r>
-          </a:p>
-        </p:txBody>
-      </p:sp>
-      <p:sp>
-        <p:nvSpPr>
-          <p:cNvPr id="23" name="TextBox 22"/>
-          <p:cNvSpPr txBox="1"/>
-          <p:nvPr/>
-        </p:nvSpPr>
-        <p:spPr>
-          <a:xfrm>
-            <a:off x="685800" y="6428232"/>
-            <a:ext cx="10972800" cy="228600"/>
-          </a:xfrm>
-          <a:prstGeom prst="rect">
-            <a:avLst/>
-          </a:prstGeom>
-          <a:noFill/>
-        </p:spPr>
-        <p:txBody>
-          <a:bodyPr wrap="none">
-            <a:spAutoFit/>
-          </a:bodyPr>
-          <a:lstStyle/>
-          <a:p>
-            <a:r>
-              <a:rPr sz="800">
+              <a:rPr sz="850">
                 <a:solidFill>
                   <a:srgbClr val="9496A1"/>
                 </a:solidFill>
                 <a:latin typeface="Consolas"/>
               </a:rPr>
-              <a:t>Source: Stillform morning -&gt; intervention -&gt; post-rating -&gt; EOD architecture</a:t>
+              <a:t>Source: Stillform App.jsx: morning/EOD loops, post-rating, and mode routing</a:t>
             </a:r>
           </a:p>
         </p:txBody>
@@ -8364,7 +8165,7 @@
         <p:spPr>
           <a:xfrm>
             <a:off x="502920" y="100584"/>
-            <a:ext cx="7315200" cy="182880"/>
+            <a:ext cx="7772400" cy="182880"/>
           </a:xfrm>
           <a:prstGeom prst="rect">
             <a:avLst/>
@@ -8378,13 +8179,13 @@
           <a:lstStyle/>
           <a:p>
             <a:r>
-              <a:rPr sz="850">
+              <a:rPr sz="900">
                 <a:solidFill>
                   <a:srgbClr val="C8922A"/>
                 </a:solidFill>
                 <a:latin typeface="Consolas"/>
               </a:rPr>
-              <a:t>STILLFORM · APPLIED SCIENCE BRIEF</a:t>
+              <a:t>STILLFORM · EXECUTIVE APPLIED SCIENCE BRIEF</a:t>
             </a:r>
           </a:p>
         </p:txBody>
@@ -8397,8 +8198,8 @@
         </p:nvSpPr>
         <p:spPr>
           <a:xfrm>
-            <a:off x="10149840" y="100584"/>
-            <a:ext cx="1554480" cy="182880"/>
+            <a:off x="10241280" y="100584"/>
+            <a:ext cx="1463040" cy="182880"/>
           </a:xfrm>
           <a:prstGeom prst="rect">
             <a:avLst/>
@@ -8413,7 +8214,7 @@
           <a:p>
             <a:pPr algn="r"/>
             <a:r>
-              <a:rPr sz="850">
+              <a:rPr sz="900">
                 <a:solidFill>
                   <a:srgbClr val="9496A1"/>
                 </a:solidFill>
@@ -8433,7 +8234,7 @@
         <p:spPr>
           <a:xfrm>
             <a:off x="640080" y="640080"/>
-            <a:ext cx="10972800" cy="1005840"/>
+            <a:ext cx="10972800" cy="960120"/>
           </a:xfrm>
           <a:prstGeom prst="rect">
             <a:avLst/>
@@ -8447,7 +8248,7 @@
           <a:lstStyle/>
           <a:p>
             <a:r>
-              <a:rPr sz="3600" b="1">
+              <a:rPr sz="3800" b="1">
                 <a:solidFill>
                   <a:srgbClr val="E8EAF0"/>
                 </a:solidFill>
@@ -8466,8 +8267,8 @@
         </p:nvSpPr>
         <p:spPr>
           <a:xfrm>
-            <a:off x="658368" y="1417320"/>
-            <a:ext cx="10972800" cy="365760"/>
+            <a:off x="676656" y="1417320"/>
+            <a:ext cx="10881360" cy="411480"/>
           </a:xfrm>
           <a:prstGeom prst="rect">
             <a:avLst/>
@@ -8481,7 +8282,7 @@
           <a:lstStyle/>
           <a:p>
             <a:r>
-              <a:rPr sz="1400">
+              <a:rPr sz="1500">
                 <a:solidFill>
                   <a:srgbClr val="9496A1"/>
                 </a:solidFill>
@@ -8501,7 +8302,7 @@
         <p:spPr>
           <a:xfrm>
             <a:off x="685800" y="1874519"/>
-            <a:ext cx="7223760" cy="4297680"/>
+            <a:ext cx="7406640" cy="4389120"/>
           </a:xfrm>
           <a:prstGeom prst="rect">
             <a:avLst/>
@@ -8509,9 +8310,9 @@
           <a:solidFill>
             <a:srgbClr val="141418"/>
           </a:solidFill>
-          <a:ln w="11430">
+          <a:ln w="12700">
             <a:solidFill>
-              <a:srgbClr val="3D3E47"/>
+              <a:srgbClr val="3A3A42"/>
             </a:solidFill>
           </a:ln>
         </p:spPr>
@@ -8547,7 +8348,7 @@
         </p:nvGraphicFramePr>
         <p:xfrm>
           <a:off x="960120" y="2240280"/>
-          <a:ext cx="6720840" cy="3611880"/>
+          <a:ext cx="6903720" cy="3611880"/>
         </p:xfrm>
         <a:graphic>
           <a:graphicData uri="http://schemas.openxmlformats.org/drawingml/2006/chart">
@@ -8563,8 +8364,8 @@
         </p:nvSpPr>
         <p:spPr>
           <a:xfrm>
-            <a:off x="8183879" y="1874519"/>
-            <a:ext cx="3520440" cy="4297680"/>
+            <a:off x="8321040" y="1874519"/>
+            <a:ext cx="3383280" cy="4389120"/>
           </a:xfrm>
           <a:prstGeom prst="rect">
             <a:avLst/>
@@ -8572,9 +8373,9 @@
           <a:solidFill>
             <a:srgbClr val="1A1A1F"/>
           </a:solidFill>
-          <a:ln w="11430">
+          <a:ln w="12700">
             <a:solidFill>
-              <a:srgbClr val="3D3E47"/>
+              <a:srgbClr val="3A3A42"/>
             </a:solidFill>
           </a:ln>
         </p:spPr>
@@ -8608,8 +8409,8 @@
         </p:nvSpPr>
         <p:spPr>
           <a:xfrm>
-            <a:off x="8348471" y="2039111"/>
-            <a:ext cx="3200400" cy="3977640"/>
+            <a:off x="8595360" y="2240280"/>
+            <a:ext cx="2926080" cy="3566160"/>
           </a:xfrm>
           <a:prstGeom prst="rect">
             <a:avLst/>
@@ -8617,27 +8418,16 @@
           <a:noFill/>
         </p:spPr>
         <p:txBody>
-          <a:bodyPr wrap="none">
+          <a:bodyPr wrap="square">
             <a:spAutoFit/>
           </a:bodyPr>
           <a:lstStyle/>
           <a:p>
-            <a:r>
-              <a:rPr sz="1500" b="1">
-                <a:solidFill>
-                  <a:srgbClr val="C8922A"/>
-                </a:solidFill>
-                <a:latin typeface="Calibri"/>
-              </a:rPr>
-              <a:t>How this works in-app</a:t>
-            </a:r>
-          </a:p>
-          <a:p>
             <a:pPr>
               <a:spcAft>
-                <a:spcPts val="600"/>
+                <a:spcPts val="900"/>
               </a:spcAft>
-              <a:defRPr sz="1200">
+              <a:defRPr sz="1500" b="1">
                 <a:solidFill>
                   <a:srgbClr val="E8EAF0"/>
                 </a:solidFill>
@@ -8645,15 +8435,15 @@
               </a:defRPr>
             </a:pPr>
             <a:r>
-              <a:t>Reliability score = (Loop x 0.65) + (Recovery x 0.35).</a:t>
+              <a:t>How Stillform proves effect:</a:t>
             </a:r>
           </a:p>
           <a:p>
             <a:pPr>
               <a:spcAft>
-                <a:spcPts val="600"/>
+                <a:spcPts val="700"/>
               </a:spcAft>
-              <a:defRPr sz="1200">
+              <a:defRPr sz="1250" b="0">
                 <a:solidFill>
                   <a:srgbClr val="E8EAF0"/>
                 </a:solidFill>
@@ -8661,15 +8451,15 @@
               </a:defRPr>
             </a:pPr>
             <a:r>
-              <a:t>14-day window for active operating signal.</a:t>
+              <a:t>Reliability score = (loop completion x 0.65) + (nudge recovery x 0.35).</a:t>
             </a:r>
           </a:p>
           <a:p>
             <a:pPr>
               <a:spcAft>
-                <a:spcPts val="600"/>
+                <a:spcPts val="700"/>
               </a:spcAft>
-              <a:defRPr sz="1200">
+              <a:defRPr sz="1250" b="0">
                 <a:solidFill>
                   <a:srgbClr val="E8EAF0"/>
                 </a:solidFill>
@@ -8677,7 +8467,23 @@
               </a:defRPr>
             </a:pPr>
             <a:r>
-              <a:t>12-week horizon for composure telemetry.</a:t>
+              <a:t>Decision window: rolling 14 days.</a:t>
+            </a:r>
+          </a:p>
+          <a:p>
+            <a:pPr>
+              <a:spcAft>
+                <a:spcPts val="700"/>
+              </a:spcAft>
+              <a:defRPr sz="1250" b="0">
+                <a:solidFill>
+                  <a:srgbClr val="E8EAF0"/>
+                </a:solidFill>
+                <a:latin typeface="Calibri"/>
+              </a:defRPr>
+            </a:pPr>
+            <a:r>
+              <a:t>Telemetry horizon: 12 weeks.</a:t>
             </a:r>
           </a:p>
         </p:txBody>
@@ -8691,7 +8497,7 @@
         <p:spPr>
           <a:xfrm>
             <a:off x="685800" y="6428232"/>
-            <a:ext cx="10972800" cy="228600"/>
+            <a:ext cx="10972800" cy="219456"/>
           </a:xfrm>
           <a:prstGeom prst="rect">
             <a:avLst/>
@@ -8705,13 +8511,13 @@
           <a:lstStyle/>
           <a:p>
             <a:r>
-              <a:rPr sz="800">
+              <a:rPr sz="850">
                 <a:solidFill>
                   <a:srgbClr val="9496A1"/>
                 </a:solidFill>
                 <a:latin typeface="Consolas"/>
               </a:rPr>
-              <a:t>Source: Stillform App.jsx reliabilityScore + loop/nudge telemetry implementation</a:t>
+              <a:t>Source: Stillform App.jsx reliabilityScore and telemetry blocks</a:t>
             </a:r>
           </a:p>
         </p:txBody>
@@ -8794,7 +8600,7 @@
         <p:spPr>
           <a:xfrm>
             <a:off x="502920" y="100584"/>
-            <a:ext cx="7315200" cy="182880"/>
+            <a:ext cx="7772400" cy="182880"/>
           </a:xfrm>
           <a:prstGeom prst="rect">
             <a:avLst/>
@@ -8808,13 +8614,13 @@
           <a:lstStyle/>
           <a:p>
             <a:r>
-              <a:rPr sz="850">
+              <a:rPr sz="900">
                 <a:solidFill>
                   <a:srgbClr val="C8922A"/>
                 </a:solidFill>
                 <a:latin typeface="Consolas"/>
               </a:rPr>
-              <a:t>STILLFORM · APPLIED SCIENCE BRIEF</a:t>
+              <a:t>STILLFORM · EXECUTIVE APPLIED SCIENCE BRIEF</a:t>
             </a:r>
           </a:p>
         </p:txBody>
@@ -8827,8 +8633,8 @@
         </p:nvSpPr>
         <p:spPr>
           <a:xfrm>
-            <a:off x="10149840" y="100584"/>
-            <a:ext cx="1554480" cy="182880"/>
+            <a:off x="10241280" y="100584"/>
+            <a:ext cx="1463040" cy="182880"/>
           </a:xfrm>
           <a:prstGeom prst="rect">
             <a:avLst/>
@@ -8843,7 +8649,7 @@
           <a:p>
             <a:pPr algn="r"/>
             <a:r>
-              <a:rPr sz="850">
+              <a:rPr sz="900">
                 <a:solidFill>
                   <a:srgbClr val="9496A1"/>
                 </a:solidFill>
@@ -8863,7 +8669,7 @@
         <p:spPr>
           <a:xfrm>
             <a:off x="640080" y="640080"/>
-            <a:ext cx="10972800" cy="1005840"/>
+            <a:ext cx="10972800" cy="960120"/>
           </a:xfrm>
           <a:prstGeom prst="rect">
             <a:avLst/>
@@ -8877,7 +8683,7 @@
           <a:lstStyle/>
           <a:p>
             <a:r>
-              <a:rPr sz="3600" b="1">
+              <a:rPr sz="3800" b="1">
                 <a:solidFill>
                   <a:srgbClr val="E8EAF0"/>
                 </a:solidFill>
@@ -8896,8 +8702,8 @@
         </p:nvSpPr>
         <p:spPr>
           <a:xfrm>
-            <a:off x="658368" y="1417320"/>
-            <a:ext cx="10972800" cy="365760"/>
+            <a:off x="676656" y="1417320"/>
+            <a:ext cx="10881360" cy="411480"/>
           </a:xfrm>
           <a:prstGeom prst="rect">
             <a:avLst/>
@@ -8911,7 +8717,7 @@
           <a:lstStyle/>
           <a:p>
             <a:r>
-              <a:rPr sz="1400">
+              <a:rPr sz="1500">
                 <a:solidFill>
                   <a:srgbClr val="9496A1"/>
                 </a:solidFill>
@@ -8930,8 +8736,8 @@
         </p:nvSpPr>
         <p:spPr>
           <a:xfrm>
-            <a:off x="804672" y="2011680"/>
-            <a:ext cx="10607040" cy="3794760"/>
+            <a:off x="822960" y="2011680"/>
+            <a:ext cx="10561320" cy="3886200"/>
           </a:xfrm>
           <a:prstGeom prst="rect">
             <a:avLst/>
@@ -8939,9 +8745,9 @@
           <a:solidFill>
             <a:srgbClr val="141418"/>
           </a:solidFill>
-          <a:ln w="11430">
+          <a:ln w="12700">
             <a:solidFill>
-              <a:srgbClr val="3D3E47"/>
+              <a:srgbClr val="3A3A42"/>
             </a:solidFill>
           </a:ln>
         </p:spPr>
@@ -8975,8 +8781,8 @@
         </p:nvSpPr>
         <p:spPr>
           <a:xfrm>
-            <a:off x="1097280" y="2423160"/>
-            <a:ext cx="10058400" cy="3063240"/>
+            <a:off x="1143000" y="2423160"/>
+            <a:ext cx="9966960" cy="3200400"/>
           </a:xfrm>
           <a:prstGeom prst="rect">
             <a:avLst/>
@@ -8984,16 +8790,16 @@
           <a:noFill/>
         </p:spPr>
         <p:txBody>
-          <a:bodyPr wrap="none">
+          <a:bodyPr wrap="square">
             <a:spAutoFit/>
           </a:bodyPr>
           <a:lstStyle/>
           <a:p>
             <a:pPr>
               <a:spcAft>
-                <a:spcPts val="800"/>
+                <a:spcPts val="900"/>
               </a:spcAft>
-              <a:defRPr sz="2500" b="1">
+              <a:defRPr sz="2900" b="1">
                 <a:solidFill>
                   <a:srgbClr val="E8EAF0"/>
                 </a:solidFill>
@@ -9001,15 +8807,15 @@
               </a:defRPr>
             </a:pPr>
             <a:r>
-              <a:t>Stillform is not psychiatric treatment software.</a:t>
+              <a:t>Stillform is a composure system for everyone.</a:t>
             </a:r>
           </a:p>
           <a:p>
             <a:pPr>
               <a:spcAft>
-                <a:spcPts val="800"/>
+                <a:spcPts val="700"/>
               </a:spcAft>
-              <a:defRPr sz="2000" b="1">
+              <a:defRPr sz="2000" b="0">
                 <a:solidFill>
                   <a:srgbClr val="E8EAF0"/>
                 </a:solidFill>
@@ -9017,15 +8823,15 @@
               </a:defRPr>
             </a:pPr>
             <a:r>
-              <a:t>It is a composure and self-awareness operating system.</a:t>
+              <a:t>Its value is not inspirational content; it is measurable state-to-action transfer under pressure.</a:t>
             </a:r>
           </a:p>
           <a:p>
             <a:pPr>
               <a:spcAft>
-                <a:spcPts val="800"/>
+                <a:spcPts val="700"/>
               </a:spcAft>
-              <a:defRPr sz="2000" b="1">
+              <a:defRPr sz="2000" b="0">
                 <a:solidFill>
                   <a:srgbClr val="E8EAF0"/>
                 </a:solidFill>
@@ -9033,7 +8839,23 @@
               </a:defRPr>
             </a:pPr>
             <a:r>
-              <a:t>Mechanism quality is judged by behavior shift, reliability, and transfer under pressure.</a:t>
+              <a:t>The deck's visuals matter only because each one ties directly to a mechanism and a telemetry proof signal.</a:t>
+            </a:r>
+          </a:p>
+          <a:p>
+            <a:pPr>
+              <a:spcAft>
+                <a:spcPts val="700"/>
+              </a:spcAft>
+              <a:defRPr sz="2000" b="0">
+                <a:solidFill>
+                  <a:srgbClr val="E8EAF0"/>
+                </a:solidFill>
+                <a:latin typeface="Calibri"/>
+              </a:defRPr>
+            </a:pPr>
+            <a:r>
+              <a:t>The release standard is simple: if the mechanism is not measurable, it is not ready to claim.</a:t>
             </a:r>
           </a:p>
         </p:txBody>
@@ -9047,7 +8869,7 @@
         <p:spPr>
           <a:xfrm>
             <a:off x="685800" y="6428232"/>
-            <a:ext cx="10972800" cy="228600"/>
+            <a:ext cx="10972800" cy="219456"/>
           </a:xfrm>
           <a:prstGeom prst="rect">
             <a:avLst/>
@@ -9061,13 +8883,13 @@
           <a:lstStyle/>
           <a:p>
             <a:r>
-              <a:rPr sz="800">
+              <a:rPr sz="850">
                 <a:solidFill>
                   <a:srgbClr val="9496A1"/>
                 </a:solidFill>
                 <a:latin typeface="Consolas"/>
               </a:rPr>
-              <a:t>Source: Stillform applied science model: metacognition, EQ, composure, impulsivity, microbias</a:t>
+              <a:t>Source: Stillform applied science model and release integrity principles</a:t>
             </a:r>
           </a:p>
         </p:txBody>

</xml_diff>

<commit_message>
Replace visuals-language with executive narrative framing
Co-authored-by: EmberEnterprises <EmberEnterprises@users.noreply.github.com>
</commit_message>
<xml_diff>
--- a/public/Stillform_Executive_Deck.pptx
+++ b/public/Stillform_Executive_Deck.pptx
@@ -5040,7 +5040,7 @@
                 </a:solidFill>
                 <a:latin typeface="Calibri"/>
               </a:rPr>
-              <a:t>Why These Visuals Matter</a:t>
+              <a:t>Executive Decision Framework</a:t>
             </a:r>
           </a:p>
         </p:txBody>
@@ -5074,7 +5074,7 @@
                 </a:solidFill>
                 <a:latin typeface="Calibri"/>
               </a:rPr>
-              <a:t>Each chart answers an executive decision question</a:t>
+              <a:t>Each section maps science to an operating decision</a:t>
             </a:r>
           </a:p>
         </p:txBody>
@@ -5160,7 +5160,7 @@
                           </a:solidFill>
                           <a:latin typeface="Calibri"/>
                         </a:rPr>
-                        <a:t>Visual</a:t>
+                        <a:t>Decision lens</a:t>
                       </a:r>
                     </a:p>
                   </a:txBody>
@@ -8839,7 +8839,7 @@
               </a:defRPr>
             </a:pPr>
             <a:r>
-              <a:t>The deck's visuals matter only because each one ties directly to a mechanism and a telemetry proof signal.</a:t>
+              <a:t>Each section only stays if it ties directly to mechanism quality and telemetry proof.</a:t>
             </a:r>
           </a:p>
           <a:p>

</xml_diff>